<commit_message>
Update presentation file for IAKA 2026 with revised content and enhancements to align with the latest project developments and insights.
</commit_message>
<xml_diff>
--- a/Kerangka_Presentasi_Peserta_IAKA_2026 (1).pptx
+++ b/Kerangka_Presentasi_Peserta_IAKA_2026 (1).pptx
@@ -14,6 +14,7 @@
     <p:sldId id="267" r:id="rId18"/>
     <p:sldId id="259" r:id="rId5"/>
     <p:sldId id="260" r:id="rId6"/>
+    <p:sldId id="268" r:id="rId20"/>
     <p:sldId id="261" r:id="rId7"/>
     <p:sldId id="262" r:id="rId8"/>
     <p:sldId id="263" r:id="rId9"/>
@@ -2265,6 +2266,484 @@
 
 <file path=ppt/slides/slide10.xml><?xml version="1.0" encoding="utf-8"?>
 <p:sld xmlns:a="http://schemas.openxmlformats.org/drawingml/2006/main" xmlns:r="http://schemas.openxmlformats.org/officeDocument/2006/relationships" xmlns:p="http://schemas.openxmlformats.org/presentationml/2006/main">
+  <p:cSld name="Slide 8">
+    <p:bg>
+      <p:bgPr>
+        <a:solidFill>
+          <a:srgbClr val="FFFFFF"/>
+        </a:solidFill>
+        <a:effectLst/>
+      </p:bgPr>
+    </p:bg>
+    <p:spTree>
+      <p:nvGrpSpPr>
+        <p:cNvPr id="1" name=""/>
+        <p:cNvGrpSpPr/>
+        <p:nvPr/>
+      </p:nvGrpSpPr>
+      <p:grpSpPr>
+        <a:xfrm>
+          <a:off x="0" y="0"/>
+          <a:ext cx="0" cy="0"/>
+          <a:chOff x="0" y="0"/>
+          <a:chExt cx="0" cy="0"/>
+        </a:xfrm>
+      </p:grpSpPr>
+      <p:sp>
+        <p:nvSpPr>
+          <p:cNvPr id="3" name="Shape 1"/>
+          <p:cNvSpPr/>
+          <p:nvPr/>
+        </p:nvSpPr>
+        <p:spPr>
+          <a:xfrm>
+            <a:off x="548640" y="619299"/>
+            <a:ext cx="731520" cy="731520"/>
+          </a:xfrm>
+          <a:prstGeom prst="ellipse">
+            <a:avLst/>
+          </a:prstGeom>
+          <a:solidFill>
+            <a:srgbClr val="6A2CC9"/>
+          </a:solidFill>
+          <a:ln/>
+          <a:effectLst>
+            <a:outerShdw blurRad="101600" dist="25400" dir="5400000" algn="bl" rotWithShape="0">
+              <a:srgbClr val="6A2CC9">
+                <a:alpha val="28000"/>
+              </a:srgbClr>
+            </a:outerShdw>
+          </a:effectLst>
+        </p:spPr>
+      </p:sp>
+      <p:sp>
+        <p:nvSpPr>
+          <p:cNvPr id="4" name="Text 2"/>
+          <p:cNvSpPr/>
+          <p:nvPr/>
+        </p:nvSpPr>
+        <p:spPr>
+          <a:xfrm>
+            <a:off x="548640" y="619299"/>
+            <a:ext cx="731520" cy="731520"/>
+          </a:xfrm>
+          <a:prstGeom prst="rect">
+            <a:avLst/>
+          </a:prstGeom>
+          <a:noFill/>
+          <a:ln/>
+        </p:spPr>
+        <p:txBody>
+          <a:bodyPr wrap="square" lIns="0" tIns="0" rIns="0" bIns="0" rtlCol="0" anchor="ctr"/>
+          <a:lstStyle/>
+          <a:p>
+            <a:pPr marL="0" indent="0" algn="ctr">
+              <a:buNone/>
+            </a:pPr>
+            <a:r>
+              <a:rPr lang="en-US" sz="2200" b="1" dirty="0">
+                <a:solidFill>
+                  <a:srgbClr val="FFFFFF"/>
+                </a:solidFill>
+                <a:latin typeface="Arial" pitchFamily="34" charset="0"/>
+                <a:ea typeface="Arial" pitchFamily="34" charset="-122"/>
+                <a:cs typeface="Arial" pitchFamily="34" charset="-120"/>
+              </a:rPr>
+              <a:t>06</a:t>
+            </a:r>
+            <a:endParaRPr lang="en-US" sz="2200" dirty="0"/>
+          </a:p>
+        </p:txBody>
+      </p:sp>
+      <p:sp>
+        <p:nvSpPr>
+          <p:cNvPr id="5" name="Text 3"/>
+          <p:cNvSpPr/>
+          <p:nvPr/>
+        </p:nvSpPr>
+        <p:spPr>
+          <a:xfrm>
+            <a:off x="1463040" y="606829"/>
+            <a:ext cx="7498080" cy="777240"/>
+          </a:xfrm>
+          <a:prstGeom prst="rect">
+            <a:avLst/>
+          </a:prstGeom>
+          <a:noFill/>
+          <a:ln/>
+        </p:spPr>
+        <p:txBody>
+          <a:bodyPr wrap="square" lIns="0" tIns="0" rIns="0" bIns="0" rtlCol="0" anchor="ctr"/>
+          <a:lstStyle/>
+          <a:p>
+            <a:pPr marL="0" indent="0">
+              <a:buNone/>
+            </a:pPr>
+            <a:r>
+              <a:rPr lang="en-US" sz="3400" b="1" dirty="0">
+                <a:solidFill>
+                  <a:srgbClr val="20288F"/>
+                </a:solidFill>
+                <a:latin typeface="Arial" pitchFamily="34" charset="0"/>
+                <a:ea typeface="Arial" pitchFamily="34" charset="-122"/>
+                <a:cs typeface="Arial" pitchFamily="34" charset="-120"/>
+              </a:rPr>
+              <a:t>Dampak</a:t>
+            </a:r>
+            <a:endParaRPr lang="en-US" sz="3400" dirty="0"/>
+          </a:p>
+        </p:txBody>
+      </p:sp>
+      <p:sp>
+        <p:nvSpPr>
+          <p:cNvPr id="8" name="Text 6"/>
+          <p:cNvSpPr/>
+          <p:nvPr/>
+        </p:nvSpPr>
+        <p:spPr>
+          <a:xfrm>
+            <a:off x="548640" y="1417320"/>
+            <a:ext cx="8229600" cy="548640"/>
+          </a:xfrm>
+          <a:prstGeom prst="rect">
+            <a:avLst/>
+          </a:prstGeom>
+          <a:noFill/>
+          <a:ln/>
+        </p:spPr>
+        <p:txBody>
+          <a:bodyPr wrap="square" lIns="0" tIns="0" rIns="0" bIns="0" rtlCol="0" anchor="ctr"/>
+          <a:lstStyle/>
+          <a:p>
+            <a:pPr marL="0" indent="0">
+              <a:buNone/>
+            </a:pPr>
+            <a:r>
+              <a:rPr lang="en-US" sz="1450" b="1" i="1" dirty="0">
+                <a:solidFill>
+                  <a:srgbClr val="6A2CC9"/>
+                </a:solidFill>
+                <a:latin typeface="Arial" pitchFamily="34" charset="0"/>
+                <a:ea typeface="Arial" pitchFamily="34" charset="-122"/>
+                <a:cs typeface="Arial" pitchFamily="34" charset="-120"/>
+              </a:rPr>
+              <a:t>Tujuan bagian ini:  </a:t>
+            </a:r>
+            <a:r>
+              <a:rPr lang="en-US" sz="1450" i="1" dirty="0">
+                <a:solidFill>
+                  <a:srgbClr val="33334D"/>
+                </a:solidFill>
+                <a:latin typeface="Arial" pitchFamily="34" charset="0"/>
+                <a:ea typeface="Arial" pitchFamily="34" charset="-122"/>
+                <a:cs typeface="Arial" pitchFamily="34" charset="-120"/>
+              </a:rPr>
+              <a:t>Sajikan dampak yang sudah tervalidasi — finansial dan non-finansial.</a:t>
+            </a:r>
+            <a:endParaRPr lang="en-US" sz="1450" dirty="0"/>
+          </a:p>
+        </p:txBody>
+      </p:sp>
+      <p:sp>
+        <p:nvSpPr>
+          <p:cNvPr id="9" name="Shape 7"/>
+          <p:cNvSpPr/>
+          <p:nvPr/>
+        </p:nvSpPr>
+        <p:spPr>
+          <a:xfrm>
+            <a:off x="548640" y="2148840"/>
+            <a:ext cx="7955280" cy="3703320"/>
+          </a:xfrm>
+          <a:prstGeom prst="roundRect">
+            <a:avLst>
+              <a:gd name="adj" fmla="val 2963"/>
+            </a:avLst>
+          </a:prstGeom>
+          <a:solidFill>
+            <a:srgbClr val="F5F1FF"/>
+          </a:solidFill>
+          <a:ln w="12700">
+            <a:solidFill>
+              <a:srgbClr val="EFE7FF"/>
+            </a:solidFill>
+            <a:prstDash val="solid"/>
+          </a:ln>
+          <a:effectLst>
+            <a:outerShdw blurRad="101600" dist="25400" dir="5400000" algn="bl" rotWithShape="0">
+              <a:srgbClr val="C9BEE8">
+                <a:alpha val="30000"/>
+              </a:srgbClr>
+            </a:outerShdw>
+          </a:effectLst>
+        </p:spPr>
+      </p:sp>
+      <p:sp>
+        <p:nvSpPr>
+          <p:cNvPr id="10" name="Text 8"/>
+          <p:cNvSpPr/>
+          <p:nvPr/>
+        </p:nvSpPr>
+        <p:spPr>
+          <a:xfrm>
+            <a:off x="868680" y="2377440"/>
+            <a:ext cx="7315200" cy="365760"/>
+          </a:xfrm>
+          <a:prstGeom prst="rect">
+            <a:avLst/>
+          </a:prstGeom>
+          <a:noFill/>
+          <a:ln/>
+        </p:spPr>
+        <p:txBody>
+          <a:bodyPr wrap="square" lIns="0" tIns="0" rIns="0" bIns="0" rtlCol="0" anchor="ctr"/>
+          <a:lstStyle/>
+          <a:p>
+            <a:pPr marL="0" indent="0">
+              <a:buNone/>
+            </a:pPr>
+            <a:r>
+              <a:rPr lang="en-US" sz="1600" b="1" dirty="0">
+                <a:solidFill>
+                  <a:srgbClr val="6A2CC9"/>
+                </a:solidFill>
+                <a:latin typeface="Arial" pitchFamily="34" charset="0"/>
+                <a:ea typeface="Arial" pitchFamily="34" charset="-122"/>
+                <a:cs typeface="Arial" pitchFamily="34" charset="-120"/>
+              </a:rPr>
+              <a:t>Yang harus disampaikan</a:t>
+            </a:r>
+            <a:endParaRPr lang="en-US" sz="1600" dirty="0"/>
+          </a:p>
+        </p:txBody>
+      </p:sp>
+      <p:sp>
+        <p:nvSpPr>
+          <p:cNvPr id="11" name="Text 9"/>
+          <p:cNvSpPr/>
+          <p:nvPr/>
+        </p:nvSpPr>
+        <p:spPr>
+          <a:xfrm>
+            <a:off x="914400" y="2880360"/>
+            <a:ext cx="7223760" cy="2697480"/>
+          </a:xfrm>
+          <a:prstGeom prst="rect">
+            <a:avLst/>
+          </a:prstGeom>
+          <a:noFill/>
+          <a:ln/>
+        </p:spPr>
+        <p:txBody>
+          <a:bodyPr wrap="square" lIns="0" tIns="0" rIns="0" bIns="0" rtlCol="0" anchor="t"/>
+          <a:lstStyle/>
+          <a:p>
+            <a:pPr marL="203200" indent="-203200">
+              <a:lnSpc>
+                <a:spcPct val="105000"/>
+              </a:lnSpc>
+              <a:spcAft>
+                <a:spcPts val="1200"/>
+              </a:spcAft>
+              <a:buSzPct val="100000"/>
+              <a:buChar char="•"/>
+            </a:pPr>
+            <a:r>
+              <a:rPr lang="en-US" sz="1450" dirty="0">
+                <a:solidFill>
+                  <a:srgbClr val="33334D"/>
+                </a:solidFill>
+                <a:latin typeface="Arial" pitchFamily="34" charset="0"/>
+                <a:ea typeface="Arial" pitchFamily="34" charset="-122"/>
+                <a:cs typeface="Arial" pitchFamily="34" charset="-120"/>
+              </a:rPr>
+              <a:t>Cost saving / cost avoidance / revenue, diukur vs baseline terverifikasi.</a:t>
+            </a:r>
+            <a:endParaRPr lang="en-US" sz="1450" dirty="0"/>
+          </a:p>
+          <a:p>
+            <a:pPr marL="203200" indent="-203200">
+              <a:lnSpc>
+                <a:spcPct val="105000"/>
+              </a:lnSpc>
+              <a:spcAft>
+                <a:spcPts val="1200"/>
+              </a:spcAft>
+              <a:buSzPct val="100000"/>
+              <a:buChar char="•"/>
+            </a:pPr>
+            <a:r>
+              <a:rPr lang="en-US" sz="1450" dirty="0">
+                <a:solidFill>
+                  <a:srgbClr val="33334D"/>
+                </a:solidFill>
+                <a:latin typeface="Arial" pitchFamily="34" charset="0"/>
+                <a:ea typeface="Arial" pitchFamily="34" charset="-122"/>
+                <a:cs typeface="Arial" pitchFamily="34" charset="-120"/>
+              </a:rPr>
+              <a:t>Nilai bersih &amp; payback period .</a:t>
+            </a:r>
+            <a:endParaRPr lang="en-US" sz="1450" dirty="0"/>
+          </a:p>
+          <a:p>
+            <a:pPr marL="203200" indent="-203200">
+              <a:lnSpc>
+                <a:spcPct val="105000"/>
+              </a:lnSpc>
+              <a:spcAft>
+                <a:spcPts val="1200"/>
+              </a:spcAft>
+              <a:buSzPct val="100000"/>
+              <a:buChar char="•"/>
+            </a:pPr>
+            <a:r>
+              <a:rPr lang="en-US" sz="1450" dirty="0">
+                <a:solidFill>
+                  <a:srgbClr val="33334D"/>
+                </a:solidFill>
+                <a:latin typeface="Arial" pitchFamily="34" charset="0"/>
+                <a:ea typeface="Arial" pitchFamily="34" charset="-122"/>
+                <a:cs typeface="Arial" pitchFamily="34" charset="-120"/>
+              </a:rPr>
+              <a:t>Dampak non-finansial: mutu, K3L, kepatuhan, kepuasan pengguna.</a:t>
+            </a:r>
+            <a:endParaRPr lang="en-US" sz="1450" dirty="0"/>
+          </a:p>
+          <a:p>
+            <a:pPr marL="203200" indent="-203200">
+              <a:lnSpc>
+                <a:spcPct val="105000"/>
+              </a:lnSpc>
+              <a:spcAft>
+                <a:spcPts val="1200"/>
+              </a:spcAft>
+              <a:buSzPct val="100000"/>
+              <a:buChar char="•"/>
+            </a:pPr>
+            <a:r>
+              <a:rPr lang="en-US" sz="1450" dirty="0">
+                <a:solidFill>
+                  <a:srgbClr val="33334D"/>
+                </a:solidFill>
+                <a:latin typeface="Arial" pitchFamily="34" charset="0"/>
+                <a:ea typeface="Arial" pitchFamily="34" charset="-122"/>
+                <a:cs typeface="Arial" pitchFamily="34" charset="-120"/>
+              </a:rPr>
+              <a:t>Keterkaitan dengan strategi perusahaan &amp; potensi replikasi.</a:t>
+            </a:r>
+            <a:endParaRPr lang="en-US" sz="1450" dirty="0"/>
+          </a:p>
+        </p:txBody>
+      </p:sp>
+      <p:sp>
+        <p:nvSpPr>
+          <p:cNvPr id="12" name="Text 10"/>
+          <p:cNvSpPr/>
+          <p:nvPr/>
+        </p:nvSpPr>
+        <p:spPr>
+          <a:xfrm>
+            <a:off x="548640" y="6400800"/>
+            <a:ext cx="11094415" cy="274320"/>
+          </a:xfrm>
+          <a:prstGeom prst="rect">
+            <a:avLst/>
+          </a:prstGeom>
+          <a:noFill/>
+          <a:ln/>
+        </p:spPr>
+        <p:txBody>
+          <a:bodyPr wrap="square" lIns="0" tIns="0" rIns="0" bIns="0" rtlCol="0" anchor="ctr"/>
+          <a:lstStyle/>
+          <a:p>
+            <a:pPr marL="0" indent="0" algn="l">
+              <a:buNone/>
+            </a:pPr>
+            <a:r>
+              <a:rPr lang="en-US" sz="950" i="1" dirty="0">
+                <a:solidFill>
+                  <a:srgbClr val="8A8A9A"/>
+                </a:solidFill>
+                <a:latin typeface="Arial" pitchFamily="34" charset="0"/>
+                <a:ea typeface="Arial" pitchFamily="34" charset="-122"/>
+                <a:cs typeface="Arial" pitchFamily="34" charset="-120"/>
+              </a:rPr>
+              <a:t>Ganti poin di atas dengan konten proyek Anda (grafik, tabel, foto, atau diagram).  ·  IAKA 2026 — Kerangka Presentasi Peserta</a:t>
+            </a:r>
+            <a:endParaRPr lang="en-US" sz="950" dirty="0"/>
+          </a:p>
+        </p:txBody>
+      </p:sp>
+      <p:pic>
+        <p:nvPicPr>
+          <p:cNvPr id="14" name="Picture 13">
+            <a:extLst>
+              <a:ext uri="{FF2B5EF4-FFF2-40B4-BE49-F238E27FC236}">
+                <a16:creationId xmlns:a16="http://schemas.microsoft.com/office/drawing/2014/main" id="{113CABC3-586E-7F22-C24E-7E3D7593E669}"/>
+              </a:ext>
+            </a:extLst>
+          </p:cNvPr>
+          <p:cNvPicPr>
+            <a:picLocks noChangeAspect="1"/>
+          </p:cNvPicPr>
+          <p:nvPr/>
+        </p:nvPicPr>
+        <p:blipFill>
+          <a:blip r:embed="rId3"/>
+          <a:stretch>
+            <a:fillRect/>
+          </a:stretch>
+        </p:blipFill>
+        <p:spPr>
+          <a:xfrm>
+            <a:off x="11056239" y="11533"/>
+            <a:ext cx="1140374" cy="634767"/>
+          </a:xfrm>
+          <a:prstGeom prst="rect">
+            <a:avLst/>
+          </a:prstGeom>
+        </p:spPr>
+      </p:pic>
+      <p:pic>
+        <p:nvPicPr>
+          <p:cNvPr id="16" name="Picture 15">
+            <a:extLst>
+              <a:ext uri="{FF2B5EF4-FFF2-40B4-BE49-F238E27FC236}">
+                <a16:creationId xmlns:a16="http://schemas.microsoft.com/office/drawing/2014/main" id="{A9D540F0-33FD-3602-4087-CD7695575FC6}"/>
+              </a:ext>
+            </a:extLst>
+          </p:cNvPr>
+          <p:cNvPicPr>
+            <a:picLocks noChangeAspect="1"/>
+          </p:cNvPicPr>
+          <p:nvPr/>
+        </p:nvPicPr>
+        <p:blipFill>
+          <a:blip r:embed="rId4"/>
+          <a:stretch>
+            <a:fillRect/>
+          </a:stretch>
+        </p:blipFill>
+        <p:spPr>
+          <a:xfrm>
+            <a:off x="-108068" y="-179554"/>
+            <a:ext cx="1448261" cy="814647"/>
+          </a:xfrm>
+          <a:prstGeom prst="rect">
+            <a:avLst/>
+          </a:prstGeom>
+        </p:spPr>
+      </p:pic>
+    </p:spTree>
+  </p:cSld>
+  <p:clrMapOvr>
+    <a:masterClrMapping/>
+  </p:clrMapOvr>
+</p:sld>
+</file>
+
+<file path=ppt/slides/slide11.xml><?xml version="1.0" encoding="utf-8"?>
+<p:sld xmlns:a="http://schemas.openxmlformats.org/drawingml/2006/main" xmlns:r="http://schemas.openxmlformats.org/officeDocument/2006/relationships" xmlns:p="http://schemas.openxmlformats.org/presentationml/2006/main">
   <p:cSld name="Slide 9">
     <p:bg>
       <p:bgPr>
@@ -2759,7 +3238,7 @@
 </p:sld>
 </file>
 
-<file path=ppt/slides/slide11.xml><?xml version="1.0" encoding="utf-8"?>
+<file path=ppt/slides/slide12.xml><?xml version="1.0" encoding="utf-8"?>
 <p:sld xmlns:a="http://schemas.openxmlformats.org/drawingml/2006/main" xmlns:r="http://schemas.openxmlformats.org/officeDocument/2006/relationships" xmlns:p="http://schemas.openxmlformats.org/presentationml/2006/main">
   <p:cSld name="Slide 10">
     <p:bg>
@@ -3237,7 +3716,7 @@
 </p:sld>
 </file>
 
-<file path=ppt/slides/slide12.xml><?xml version="1.0" encoding="utf-8"?>
+<file path=ppt/slides/slide13.xml><?xml version="1.0" encoding="utf-8"?>
 <p:sld xmlns:a="http://schemas.openxmlformats.org/drawingml/2006/main" xmlns:r="http://schemas.openxmlformats.org/officeDocument/2006/relationships" xmlns:p="http://schemas.openxmlformats.org/presentationml/2006/main">
   <p:cSld name="Slide 11">
     <p:bg>
@@ -7613,7 +8092,7 @@
                 </a:solidFill>
                 <a:latin typeface="Arial"/>
               </a:rPr>
-              <a:t>03</a:t>
+              <a:t>03.1</a:t>
             </a:r>
           </a:p>
         </p:txBody>
@@ -7648,7 +8127,7 @@
                 </a:solidFill>
                 <a:latin typeface="Arial"/>
               </a:rPr>
-              <a:t>Analisis Penyebab</a:t>
+              <a:t>Analisis Penyebab: Diagram Fishbone 4M &amp; Bukti Data Silo</a:t>
             </a:r>
           </a:p>
         </p:txBody>
@@ -7691,32 +8170,64 @@
                 </a:solidFill>
                 <a:latin typeface="Arial"/>
               </a:rPr>
-              <a:t>Tunjukkan akar masalah, bukan sekadar gejalanya.</a:t>
-            </a:r>
-          </a:p>
-        </p:txBody>
-      </p:sp>
-      <p:sp>
-        <p:nvSpPr>
-          <p:cNvPr id="7" name="Rounded Rectangle 6"/>
-          <p:cNvSpPr/>
-          <p:nvPr/>
-        </p:nvSpPr>
-        <p:spPr>
-          <a:xfrm>
-            <a:off x="548640" y="2011680"/>
-            <a:ext cx="7955279" cy="3840480"/>
-          </a:xfrm>
-          <a:prstGeom prst="roundRect">
+              <a:t>Tunjukkan dekonstruksi variabel penyebab lintas 4M dan buktikan temuan empiris keterpisahan data (data silo) di lapangan.</a:t>
+            </a:r>
+          </a:p>
+        </p:txBody>
+      </p:sp>
+      <p:sp>
+        <p:nvSpPr>
+          <p:cNvPr id="7" name="TextBox 6"/>
+          <p:cNvSpPr txBox="1"/>
+          <p:nvPr/>
+        </p:nvSpPr>
+        <p:spPr>
+          <a:xfrm>
+            <a:off x="548640" y="6419088"/>
+            <a:ext cx="11091672" cy="219456"/>
+          </a:xfrm>
+          <a:prstGeom prst="rect">
+            <a:avLst/>
+          </a:prstGeom>
+          <a:noFill/>
+        </p:spPr>
+        <p:txBody>
+          <a:bodyPr wrap="square" lIns="0" tIns="0" rIns="0" bIns="0">
+            <a:spAutoFit/>
+          </a:bodyPr>
+          <a:lstStyle/>
+          <a:p>
+            <a:r>
+              <a:rPr sz="850">
+                <a:solidFill>
+                  <a:srgbClr val="6E6E82"/>
+                </a:solidFill>
+                <a:latin typeface="Arial"/>
+              </a:rPr>
+              <a:t>IAKA 2026 — Kerangka Presentasi Peserta  ·  DSS SIRINE 4.0 Unit Cetak Pita Cukai</a:t>
+            </a:r>
+          </a:p>
+        </p:txBody>
+      </p:sp>
+      <p:sp>
+        <p:nvSpPr>
+          <p:cNvPr id="8" name="Rectangle 7"/>
+          <p:cNvSpPr/>
+          <p:nvPr/>
+        </p:nvSpPr>
+        <p:spPr>
+          <a:xfrm>
+            <a:off x="548640" y="1755648"/>
+            <a:ext cx="5394960" cy="329184"/>
+          </a:xfrm>
+          <a:prstGeom prst="rect">
             <a:avLst/>
           </a:prstGeom>
           <a:solidFill>
-            <a:srgbClr val="F8F6FE"/>
+            <a:srgbClr val="20288F"/>
           </a:solidFill>
-          <a:ln w="12700">
-            <a:solidFill>
-              <a:srgbClr val="D9CEF7"/>
-            </a:solidFill>
+          <a:ln>
+            <a:noFill/>
           </a:ln>
         </p:spPr>
         <p:style>
@@ -7734,100 +8245,734 @@
           </a:fontRef>
         </p:style>
         <p:txBody>
-          <a:bodyPr rtlCol="0" anchor="ctr" wrap="square" lIns="228600" rIns="228600" tIns="228600" bIns="182880"/>
+          <a:bodyPr rtlCol="0" anchor="ctr" tIns="36576" bIns="36576"/>
           <a:lstStyle/>
           <a:p>
             <a:pPr algn="ctr"/>
             <a:r>
-              <a:rPr sz="1300" b="1">
+              <a:rPr sz="1050" b="1">
+                <a:solidFill>
+                  <a:srgbClr val="FFFFFF"/>
+                </a:solidFill>
+                <a:latin typeface="Arial"/>
+              </a:rPr>
+              <a:t>1. METODE ANALISIS: DIAGRAM TULANG IKAN (FISHBONE 4M)</a:t>
+            </a:r>
+          </a:p>
+        </p:txBody>
+      </p:sp>
+      <p:sp>
+        <p:nvSpPr>
+          <p:cNvPr id="9" name="Rounded Rectangle 8"/>
+          <p:cNvSpPr/>
+          <p:nvPr/>
+        </p:nvSpPr>
+        <p:spPr>
+          <a:xfrm>
+            <a:off x="548640" y="2084831"/>
+            <a:ext cx="5394960" cy="3730752"/>
+          </a:xfrm>
+          <a:prstGeom prst="roundRect">
+            <a:avLst/>
+          </a:prstGeom>
+          <a:solidFill>
+            <a:srgbClr val="F4F7FE"/>
+          </a:solidFill>
+          <a:ln>
+            <a:solidFill>
+              <a:srgbClr val="D2DCF5"/>
+            </a:solidFill>
+          </a:ln>
+        </p:spPr>
+        <p:style>
+          <a:lnRef idx="1">
+            <a:schemeClr val="accent1"/>
+          </a:lnRef>
+          <a:fillRef idx="3">
+            <a:schemeClr val="accent1"/>
+          </a:fillRef>
+          <a:effectRef idx="2">
+            <a:schemeClr val="accent1"/>
+          </a:effectRef>
+          <a:fontRef idx="minor">
+            <a:schemeClr val="lt1"/>
+          </a:fontRef>
+        </p:style>
+        <p:txBody>
+          <a:bodyPr rtlCol="0" anchor="ctr"/>
+          <a:lstStyle/>
+          <a:p>
+            <a:pPr algn="ctr"/>
+          </a:p>
+        </p:txBody>
+      </p:sp>
+      <p:sp>
+        <p:nvSpPr>
+          <p:cNvPr id="10" name="Rounded Rectangle 9"/>
+          <p:cNvSpPr/>
+          <p:nvPr/>
+        </p:nvSpPr>
+        <p:spPr>
+          <a:xfrm>
+            <a:off x="658368" y="2157984"/>
+            <a:ext cx="5175504" cy="1874519"/>
+          </a:xfrm>
+          <a:prstGeom prst="roundRect">
+            <a:avLst/>
+          </a:prstGeom>
+          <a:solidFill>
+            <a:srgbClr val="FFFFFF"/>
+          </a:solidFill>
+          <a:ln>
+            <a:solidFill>
+              <a:srgbClr val="D2DCF5"/>
+            </a:solidFill>
+          </a:ln>
+        </p:spPr>
+        <p:style>
+          <a:lnRef idx="1">
+            <a:schemeClr val="accent1"/>
+          </a:lnRef>
+          <a:fillRef idx="3">
+            <a:schemeClr val="accent1"/>
+          </a:fillRef>
+          <a:effectRef idx="2">
+            <a:schemeClr val="accent1"/>
+          </a:effectRef>
+          <a:fontRef idx="minor">
+            <a:schemeClr val="lt1"/>
+          </a:fontRef>
+        </p:style>
+        <p:txBody>
+          <a:bodyPr rtlCol="0" anchor="ctr"/>
+          <a:lstStyle/>
+          <a:p>
+            <a:pPr algn="ctr"/>
+          </a:p>
+        </p:txBody>
+      </p:sp>
+      <p:pic>
+        <p:nvPicPr>
+          <p:cNvPr id="11" name="Picture 10" descr="image.png"/>
+          <p:cNvPicPr>
+            <a:picLocks noChangeAspect="1"/>
+          </p:cNvPicPr>
+          <p:nvPr/>
+        </p:nvPicPr>
+        <p:blipFill>
+          <a:blip r:embed="rId4"/>
+          <a:stretch>
+            <a:fillRect/>
+          </a:stretch>
+        </p:blipFill>
+        <p:spPr>
+          <a:xfrm>
+            <a:off x="731520" y="2212848"/>
+            <a:ext cx="5029200" cy="1755648"/>
+          </a:xfrm>
+          <a:prstGeom prst="rect">
+            <a:avLst/>
+          </a:prstGeom>
+        </p:spPr>
+      </p:pic>
+      <p:sp>
+        <p:nvSpPr>
+          <p:cNvPr id="12" name="Rounded Rectangle 11"/>
+          <p:cNvSpPr/>
+          <p:nvPr/>
+        </p:nvSpPr>
+        <p:spPr>
+          <a:xfrm>
+            <a:off x="658368" y="4096512"/>
+            <a:ext cx="5175504" cy="1627632"/>
+          </a:xfrm>
+          <a:prstGeom prst="roundRect">
+            <a:avLst/>
+          </a:prstGeom>
+          <a:solidFill>
+            <a:srgbClr val="FFFFFF"/>
+          </a:solidFill>
+          <a:ln>
+            <a:solidFill>
+              <a:srgbClr val="D9CEF7"/>
+            </a:solidFill>
+          </a:ln>
+        </p:spPr>
+        <p:style>
+          <a:lnRef idx="1">
+            <a:schemeClr val="accent1"/>
+          </a:lnRef>
+          <a:fillRef idx="3">
+            <a:schemeClr val="accent1"/>
+          </a:fillRef>
+          <a:effectRef idx="2">
+            <a:schemeClr val="accent1"/>
+          </a:effectRef>
+          <a:fontRef idx="minor">
+            <a:schemeClr val="lt1"/>
+          </a:fontRef>
+        </p:style>
+        <p:txBody>
+          <a:bodyPr rtlCol="0" anchor="ctr" wrap="square"/>
+          <a:lstStyle/>
+          <a:p>
+            <a:pPr algn="ctr">
+              <a:spcAft>
+                <a:spcPts val="200"/>
+              </a:spcAft>
+            </a:pPr>
+            <a:r>
+              <a:rPr sz="850" b="1">
+                <a:solidFill>
+                  <a:srgbClr val="20288F"/>
+                </a:solidFill>
+                <a:latin typeface="Arial"/>
+              </a:rPr>
+              <a:t>RINGKASAN DEKONSTRUKSI 4 PILAR FISHBONE DI LAPANGAN:</a:t>
+            </a:r>
+          </a:p>
+          <a:p>
+            <a:pPr>
+              <a:spcAft>
+                <a:spcPts val="150"/>
+              </a:spcAft>
+            </a:pPr>
+            <a:r>
+              <a:rPr sz="780" b="1">
                 <a:solidFill>
                   <a:srgbClr val="6A2CC9"/>
                 </a:solidFill>
                 <a:latin typeface="Arial"/>
               </a:rPr>
-              <a:t>Yang harus disampaikan</a:t>
+              <a:t>• MAN &amp; METHOD: </a:t>
+            </a:r>
+            <a:r>
+              <a:rPr sz="780" b="0">
+                <a:solidFill>
+                  <a:srgbClr val="2A2A3D"/>
+                </a:solidFill>
+                <a:latin typeface="Arial"/>
+              </a:rPr>
+              <a:t>Kelelahan visual shift malam (23–07) &amp; belum ada standar digital setting awal (make-ready) -&gt; afval awal tinggi per PO.</a:t>
             </a:r>
           </a:p>
           <a:p>
             <a:pPr>
-              <a:spcBef>
-                <a:spcPts val="1200"/>
-              </a:spcBef>
-            </a:pPr>
-            <a:r>
-              <a:rPr sz="1100">
+              <a:spcAft>
+                <a:spcPts val="150"/>
+              </a:spcAft>
+            </a:pPr>
+            <a:r>
+              <a:rPr sz="780" b="1">
+                <a:solidFill>
+                  <a:srgbClr val="C62828"/>
+                </a:solidFill>
+                <a:latin typeface="Arial"/>
+              </a:rPr>
+              <a:t>• MACHINE &amp; MATERIAL: </a:t>
+            </a:r>
+            <a:r>
+              <a:rPr sz="780" b="0">
                 <a:solidFill>
                   <a:srgbClr val="2A2A3D"/>
                 </a:solidFill>
                 <a:latin typeface="Arial"/>
               </a:rPr>
-              <a:t>•  Metode analisis: 5 Why atau Fishbone (cukup satu gambar ringkas).</a:t>
+              <a:t>Penurunan performa rol karet mengeras/licin, blanket fatigue, penjepit silinder melemah, &amp; kertas higroskopis rentan gelombang (plooi).</a:t>
             </a:r>
           </a:p>
           <a:p>
             <a:pPr>
-              <a:spcBef>
-                <a:spcPts val="1200"/>
-              </a:spcBef>
-            </a:pPr>
-            <a:r>
-              <a:rPr sz="1100">
+              <a:spcAft>
+                <a:spcPts val="150"/>
+              </a:spcAft>
+            </a:pPr>
+            <a:r>
+              <a:rPr sz="780" b="1">
+                <a:solidFill>
+                  <a:srgbClr val="20288F"/>
+                </a:solidFill>
+                <a:latin typeface="Arial"/>
+              </a:rPr>
+              <a:t>• AKIBAT OPERASIONAL: </a:t>
+            </a:r>
+            <a:r>
+              <a:rPr sz="780" b="1">
+                <a:solidFill>
+                  <a:srgbClr val="C62828"/>
+                </a:solidFill>
+                <a:latin typeface="Arial"/>
+              </a:rPr>
+              <a:t>Inschiet rata-rata 4,61% (Puncak Q4: 5,11% | Kerugian Rp 24,56 Miliar/Tahun | Downtime &gt; 8 jam akibat inspeksi acak bergilir).</a:t>
+            </a:r>
+          </a:p>
+        </p:txBody>
+      </p:sp>
+      <p:sp>
+        <p:nvSpPr>
+          <p:cNvPr id="13" name="Rectangle 12"/>
+          <p:cNvSpPr/>
+          <p:nvPr/>
+        </p:nvSpPr>
+        <p:spPr>
+          <a:xfrm>
+            <a:off x="6199632" y="1755648"/>
+            <a:ext cx="5440680" cy="329184"/>
+          </a:xfrm>
+          <a:prstGeom prst="rect">
+            <a:avLst/>
+          </a:prstGeom>
+          <a:solidFill>
+            <a:srgbClr val="6A2CC9"/>
+          </a:solidFill>
+          <a:ln>
+            <a:noFill/>
+          </a:ln>
+        </p:spPr>
+        <p:style>
+          <a:lnRef idx="1">
+            <a:schemeClr val="accent1"/>
+          </a:lnRef>
+          <a:fillRef idx="3">
+            <a:schemeClr val="accent1"/>
+          </a:fillRef>
+          <a:effectRef idx="2">
+            <a:schemeClr val="accent1"/>
+          </a:effectRef>
+          <a:fontRef idx="minor">
+            <a:schemeClr val="lt1"/>
+          </a:fontRef>
+        </p:style>
+        <p:txBody>
+          <a:bodyPr rtlCol="0" anchor="ctr" tIns="36576" bIns="36576"/>
+          <a:lstStyle/>
+          <a:p>
+            <a:pPr algn="ctr"/>
+            <a:r>
+              <a:rPr sz="1050" b="1">
+                <a:solidFill>
+                  <a:srgbClr val="FFFFFF"/>
+                </a:solidFill>
+                <a:latin typeface="Arial"/>
+              </a:rPr>
+              <a:t>2. TEMUAN FAKTA &amp; BUKTI EMPIRIS LAPANGAN (DATA SILO)</a:t>
+            </a:r>
+          </a:p>
+        </p:txBody>
+      </p:sp>
+      <p:sp>
+        <p:nvSpPr>
+          <p:cNvPr id="14" name="Rounded Rectangle 13"/>
+          <p:cNvSpPr/>
+          <p:nvPr/>
+        </p:nvSpPr>
+        <p:spPr>
+          <a:xfrm>
+            <a:off x="6199632" y="2084831"/>
+            <a:ext cx="5440680" cy="3730752"/>
+          </a:xfrm>
+          <a:prstGeom prst="roundRect">
+            <a:avLst/>
+          </a:prstGeom>
+          <a:solidFill>
+            <a:srgbClr val="F8F6FE"/>
+          </a:solidFill>
+          <a:ln>
+            <a:solidFill>
+              <a:srgbClr val="D9CEF7"/>
+            </a:solidFill>
+          </a:ln>
+        </p:spPr>
+        <p:style>
+          <a:lnRef idx="1">
+            <a:schemeClr val="accent1"/>
+          </a:lnRef>
+          <a:fillRef idx="3">
+            <a:schemeClr val="accent1"/>
+          </a:fillRef>
+          <a:effectRef idx="2">
+            <a:schemeClr val="accent1"/>
+          </a:effectRef>
+          <a:fontRef idx="minor">
+            <a:schemeClr val="lt1"/>
+          </a:fontRef>
+        </p:style>
+        <p:txBody>
+          <a:bodyPr rtlCol="0" anchor="ctr"/>
+          <a:lstStyle/>
+          <a:p>
+            <a:pPr algn="ctr"/>
+          </a:p>
+        </p:txBody>
+      </p:sp>
+      <p:sp>
+        <p:nvSpPr>
+          <p:cNvPr id="15" name="Rounded Rectangle 14"/>
+          <p:cNvSpPr/>
+          <p:nvPr/>
+        </p:nvSpPr>
+        <p:spPr>
+          <a:xfrm>
+            <a:off x="6327648" y="2157984"/>
+            <a:ext cx="5184648" cy="1078992"/>
+          </a:xfrm>
+          <a:prstGeom prst="roundRect">
+            <a:avLst/>
+          </a:prstGeom>
+          <a:solidFill>
+            <a:srgbClr val="FFFFFF"/>
+          </a:solidFill>
+          <a:ln>
+            <a:solidFill>
+              <a:srgbClr val="D2DCF5"/>
+            </a:solidFill>
+          </a:ln>
+        </p:spPr>
+        <p:style>
+          <a:lnRef idx="1">
+            <a:schemeClr val="accent1"/>
+          </a:lnRef>
+          <a:fillRef idx="3">
+            <a:schemeClr val="accent1"/>
+          </a:fillRef>
+          <a:effectRef idx="2">
+            <a:schemeClr val="accent1"/>
+          </a:effectRef>
+          <a:fontRef idx="minor">
+            <a:schemeClr val="lt1"/>
+          </a:fontRef>
+        </p:style>
+        <p:txBody>
+          <a:bodyPr rtlCol="0" anchor="ctr" wrap="square"/>
+          <a:lstStyle/>
+          <a:p>
+            <a:pPr algn="ctr">
+              <a:spcAft>
+                <a:spcPts val="200"/>
+              </a:spcAft>
+            </a:pPr>
+            <a:r>
+              <a:rPr sz="900" b="1">
+                <a:solidFill>
+                  <a:srgbClr val="20288F"/>
+                </a:solidFill>
+                <a:latin typeface="Arial"/>
+              </a:rPr>
+              <a:t>BUKTI 1: Data Transaksi SAP Terkunci Mentah (Dormant Data)</a:t>
+            </a:r>
+          </a:p>
+          <a:p>
+            <a:pPr>
+              <a:spcAft>
+                <a:spcPts val="200"/>
+              </a:spcAft>
+            </a:pPr>
+            <a:r>
+              <a:rPr sz="800" b="1">
+                <a:solidFill>
+                  <a:srgbClr val="20288F"/>
+                </a:solidFill>
+                <a:latin typeface="Arial"/>
+              </a:rPr>
+              <a:t>• Kondisi Sistem: </a:t>
+            </a:r>
+            <a:r>
+              <a:rPr sz="800">
                 <a:solidFill>
                   <a:srgbClr val="2A2A3D"/>
                 </a:solidFill>
                 <a:latin typeface="Arial"/>
               </a:rPr>
-              <a:t>•  Akar masalah utama yang akan diselesaikan.</a:t>
+              <a:t>Modul SAP ZPPRSIPPC0012 memuat data PO &amp; hasil cetak, tetapi tersaji dalam tabel CSV mentah puluhan kolom di PC kantor.</a:t>
+            </a:r>
+          </a:p>
+          <a:p>
+            <a:r>
+              <a:rPr sz="800" b="1">
+                <a:solidFill>
+                  <a:srgbClr val="20288F"/>
+                </a:solidFill>
+                <a:latin typeface="Arial"/>
+              </a:rPr>
+              <a:t>• Fakta Lapangan: </a:t>
+            </a:r>
+            <a:r>
+              <a:rPr sz="800">
+                <a:solidFill>
+                  <a:srgbClr val="2A2A3D"/>
+                </a:solidFill>
+                <a:latin typeface="Arial"/>
+              </a:rPr>
+              <a:t>Data pasif dan tidak bisa diolah langsung di meja mesin; pengawas tidak memiliki visualisasi tren performa harian per mesin.</a:t>
+            </a:r>
+          </a:p>
+        </p:txBody>
+      </p:sp>
+      <p:sp>
+        <p:nvSpPr>
+          <p:cNvPr id="16" name="Rounded Rectangle 15"/>
+          <p:cNvSpPr/>
+          <p:nvPr/>
+        </p:nvSpPr>
+        <p:spPr>
+          <a:xfrm>
+            <a:off x="6327648" y="3291840"/>
+            <a:ext cx="5184648" cy="1078992"/>
+          </a:xfrm>
+          <a:prstGeom prst="roundRect">
+            <a:avLst/>
+          </a:prstGeom>
+          <a:solidFill>
+            <a:srgbClr val="FFFFFF"/>
+          </a:solidFill>
+          <a:ln>
+            <a:solidFill>
+              <a:srgbClr val="D9CEF7"/>
+            </a:solidFill>
+          </a:ln>
+        </p:spPr>
+        <p:style>
+          <a:lnRef idx="1">
+            <a:schemeClr val="accent1"/>
+          </a:lnRef>
+          <a:fillRef idx="3">
+            <a:schemeClr val="accent1"/>
+          </a:fillRef>
+          <a:effectRef idx="2">
+            <a:schemeClr val="accent1"/>
+          </a:effectRef>
+          <a:fontRef idx="minor">
+            <a:schemeClr val="lt1"/>
+          </a:fontRef>
+        </p:style>
+        <p:txBody>
+          <a:bodyPr rtlCol="0" anchor="ctr" wrap="square"/>
+          <a:lstStyle/>
+          <a:p>
+            <a:pPr algn="ctr">
+              <a:spcAft>
+                <a:spcPts val="200"/>
+              </a:spcAft>
+            </a:pPr>
+            <a:r>
+              <a:rPr sz="900" b="1">
+                <a:solidFill>
+                  <a:srgbClr val="6A2CC9"/>
+                </a:solidFill>
+                <a:latin typeface="Arial"/>
+              </a:rPr>
+              <a:t>BUKTI 2: Data Mutu QC Hanya Ringkasan Global (Attribution Blindness)</a:t>
             </a:r>
           </a:p>
           <a:p>
             <a:pPr>
-              <a:spcBef>
-                <a:spcPts val="1200"/>
-              </a:spcBef>
-            </a:pPr>
-            <a:r>
-              <a:rPr sz="1100">
+              <a:spcAft>
+                <a:spcPts val="200"/>
+              </a:spcAft>
+            </a:pPr>
+            <a:r>
+              <a:rPr sz="800" b="1">
+                <a:solidFill>
+                  <a:srgbClr val="6A2CC9"/>
+                </a:solidFill>
+                <a:latin typeface="Arial"/>
+              </a:rPr>
+              <a:t>• Kondisi Sistem: </a:t>
+            </a:r>
+            <a:r>
+              <a:rPr sz="800">
                 <a:solidFill>
                   <a:srgbClr val="2A2A3D"/>
                 </a:solidFill>
                 <a:latin typeface="Arial"/>
               </a:rPr>
-              <a:t>•  Temuan / bukti yang mendukung akar masalah tersebut.</a:t>
-            </a:r>
-          </a:p>
-        </p:txBody>
-      </p:sp>
-      <p:sp>
-        <p:nvSpPr>
-          <p:cNvPr id="8" name="TextBox 7"/>
-          <p:cNvSpPr txBox="1"/>
-          <p:nvPr/>
-        </p:nvSpPr>
-        <p:spPr>
-          <a:xfrm>
-            <a:off x="548640" y="6419088"/>
-            <a:ext cx="11091672" cy="219456"/>
-          </a:xfrm>
-          <a:prstGeom prst="rect">
-            <a:avLst/>
-          </a:prstGeom>
-          <a:noFill/>
-        </p:spPr>
-        <p:txBody>
-          <a:bodyPr wrap="square" lIns="0" tIns="0" rIns="0" bIns="0">
-            <a:spAutoFit/>
-          </a:bodyPr>
-          <a:lstStyle/>
-          <a:p>
-            <a:r>
-              <a:rPr sz="850">
-                <a:solidFill>
-                  <a:srgbClr val="6E6E82"/>
-                </a:solidFill>
-                <a:latin typeface="Arial"/>
-              </a:rPr>
-              <a:t>Ganti poin di atas dengan konten proyek Anda (grafik, tabel, foto, atau diagram).  ·  IAKA 2026 — Kerangka Presentasi Peserta</a:t>
+              <a:t>Laporan QC Verifikasi mencatat lembar cacat per jenis (blobor, noda, dll), namun hanya sebagai total akumulasi unit global.</a:t>
+            </a:r>
+          </a:p>
+          <a:p>
+            <a:r>
+              <a:rPr sz="800" b="1">
+                <a:solidFill>
+                  <a:srgbClr val="6A2CC9"/>
+                </a:solidFill>
+                <a:latin typeface="Arial"/>
+              </a:rPr>
+              <a:t>• Fakta Lapangan: </a:t>
+            </a:r>
+            <a:r>
+              <a:rPr sz="800">
+                <a:solidFill>
+                  <a:srgbClr val="2A2A3D"/>
+                </a:solidFill>
+                <a:latin typeface="Arial"/>
+              </a:rPr>
+              <a:t>Ketiadaan nomor mesin, PO, &amp; shift -&gt; Kebutaan atribusi: teknisi tidak tahu mesin target dan pembinaan operator bias.</a:t>
+            </a:r>
+          </a:p>
+        </p:txBody>
+      </p:sp>
+      <p:sp>
+        <p:nvSpPr>
+          <p:cNvPr id="17" name="Rounded Rectangle 16"/>
+          <p:cNvSpPr/>
+          <p:nvPr/>
+        </p:nvSpPr>
+        <p:spPr>
+          <a:xfrm>
+            <a:off x="6327648" y="4425696"/>
+            <a:ext cx="5184648" cy="1298448"/>
+          </a:xfrm>
+          <a:prstGeom prst="roundRect">
+            <a:avLst/>
+          </a:prstGeom>
+          <a:solidFill>
+            <a:srgbClr val="FFFFFF"/>
+          </a:solidFill>
+          <a:ln>
+            <a:solidFill>
+              <a:srgbClr val="F5C2C2"/>
+            </a:solidFill>
+          </a:ln>
+        </p:spPr>
+        <p:style>
+          <a:lnRef idx="1">
+            <a:schemeClr val="accent1"/>
+          </a:lnRef>
+          <a:fillRef idx="3">
+            <a:schemeClr val="accent1"/>
+          </a:fillRef>
+          <a:effectRef idx="2">
+            <a:schemeClr val="accent1"/>
+          </a:effectRef>
+          <a:fontRef idx="minor">
+            <a:schemeClr val="lt1"/>
+          </a:fontRef>
+        </p:style>
+        <p:txBody>
+          <a:bodyPr rtlCol="0" anchor="ctr" wrap="square"/>
+          <a:lstStyle/>
+          <a:p>
+            <a:pPr algn="ctr">
+              <a:spcAft>
+                <a:spcPts val="200"/>
+              </a:spcAft>
+            </a:pPr>
+            <a:r>
+              <a:rPr sz="900" b="1">
+                <a:solidFill>
+                  <a:srgbClr val="C62828"/>
+                </a:solidFill>
+                <a:latin typeface="Arial"/>
+              </a:rPr>
+              <a:t>BUKTI 3: Data Penugasan Terperangkap di Kertas (The Paper Trap)</a:t>
+            </a:r>
+          </a:p>
+          <a:p>
+            <a:pPr>
+              <a:spcAft>
+                <a:spcPts val="200"/>
+              </a:spcAft>
+            </a:pPr>
+            <a:r>
+              <a:rPr sz="800" b="1">
+                <a:solidFill>
+                  <a:srgbClr val="C62828"/>
+                </a:solidFill>
+                <a:latin typeface="Arial"/>
+              </a:rPr>
+              <a:t>• Kondisi Sistem: </a:t>
+            </a:r>
+            <a:r>
+              <a:rPr sz="800">
+                <a:solidFill>
+                  <a:srgbClr val="2A2A3D"/>
+                </a:solidFill>
+                <a:latin typeface="Arial"/>
+              </a:rPr>
+              <a:t>Nomor mesin, PO, shift, nama operator, &amp; hasil cetak (LK) ditulis manual dengan pulpen pada buku folio fisik di meja mesin.</a:t>
+            </a:r>
+          </a:p>
+          <a:p>
+            <a:r>
+              <a:rPr sz="800" b="1">
+                <a:solidFill>
+                  <a:srgbClr val="C62828"/>
+                </a:solidFill>
+                <a:latin typeface="Arial"/>
+              </a:rPr>
+              <a:t>• Fakta Lapangan: </a:t>
+            </a:r>
+            <a:r>
+              <a:rPr sz="800">
+                <a:solidFill>
+                  <a:srgbClr val="2A2A3D"/>
+                </a:solidFill>
+                <a:latin typeface="Arial"/>
+              </a:rPr>
+              <a:t>Buku fisik terisolasi &amp; baru direkap kuartalan saat penilaian pegawai; data rawan hilang/rusak terkena tinta/air, dan feedback kinerja tertunda berbulan-bulan.</a:t>
+            </a:r>
+          </a:p>
+        </p:txBody>
+      </p:sp>
+      <p:sp>
+        <p:nvSpPr>
+          <p:cNvPr id="18" name="Rounded Rectangle 17"/>
+          <p:cNvSpPr/>
+          <p:nvPr/>
+        </p:nvSpPr>
+        <p:spPr>
+          <a:xfrm>
+            <a:off x="548640" y="5888736"/>
+            <a:ext cx="11091672" cy="457200"/>
+          </a:xfrm>
+          <a:prstGeom prst="roundRect">
+            <a:avLst/>
+          </a:prstGeom>
+          <a:solidFill>
+            <a:srgbClr val="F4F7FE"/>
+          </a:solidFill>
+          <a:ln>
+            <a:solidFill>
+              <a:srgbClr val="20288F"/>
+            </a:solidFill>
+          </a:ln>
+        </p:spPr>
+        <p:style>
+          <a:lnRef idx="1">
+            <a:schemeClr val="accent1"/>
+          </a:lnRef>
+          <a:fillRef idx="3">
+            <a:schemeClr val="accent1"/>
+          </a:fillRef>
+          <a:effectRef idx="2">
+            <a:schemeClr val="accent1"/>
+          </a:effectRef>
+          <a:fontRef idx="minor">
+            <a:schemeClr val="lt1"/>
+          </a:fontRef>
+        </p:style>
+        <p:txBody>
+          <a:bodyPr rtlCol="0" anchor="ctr" wrap="square" lIns="109728" rIns="109728" tIns="36576" bIns="36576"/>
+          <a:lstStyle/>
+          <a:p>
+            <a:pPr algn="ctr"/>
+            <a:r>
+              <a:rPr sz="880" b="1">
+                <a:solidFill>
+                  <a:srgbClr val="20288F"/>
+                </a:solidFill>
+                <a:latin typeface="Arial"/>
+              </a:rPr>
+              <a:t>• Business Insight:  </a:t>
+            </a:r>
+            <a:r>
+              <a:rPr sz="880">
+                <a:solidFill>
+                  <a:srgbClr val="2A2A3D"/>
+                </a:solidFill>
+                <a:latin typeface="Arial"/>
+              </a:rPr>
+              <a:t>Penyebab utama tingginya inschiet bukan ketiadaan SOP, melainkan terputusnya aliran data (Data Silo) antara SAP di kantor, modul QC Verifikasi, dan buku folio di meja mesin. Tanpa integrasi data, perbaikan mesin tetap spekulatif (&gt; 8 jam) dan pembinaan operator terhambat.</a:t>
             </a:r>
           </a:p>
         </p:txBody>
@@ -7841,6 +8986,1251 @@
 </file>
 
 <file path=ppt/slides/slide7.xml><?xml version="1.0" encoding="utf-8"?>
+<p:sld xmlns:a="http://schemas.openxmlformats.org/drawingml/2006/main" xmlns:p="http://schemas.openxmlformats.org/presentationml/2006/main" xmlns:r="http://schemas.openxmlformats.org/officeDocument/2006/relationships">
+  <p:cSld>
+    <p:spTree>
+      <p:nvGrpSpPr>
+        <p:cNvPr id="1" name=""/>
+        <p:cNvGrpSpPr/>
+        <p:nvPr/>
+      </p:nvGrpSpPr>
+      <p:grpSpPr/>
+      <p:pic>
+        <p:nvPicPr>
+          <p:cNvPr id="2" name="Picture 1" descr="image.png"/>
+          <p:cNvPicPr>
+            <a:picLocks noChangeAspect="1"/>
+          </p:cNvPicPr>
+          <p:nvPr/>
+        </p:nvPicPr>
+        <p:blipFill>
+          <a:blip r:embed="rId2"/>
+          <a:stretch>
+            <a:fillRect/>
+          </a:stretch>
+        </p:blipFill>
+        <p:spPr>
+          <a:xfrm>
+            <a:off x="-107899" y="-179222"/>
+            <a:ext cx="1448409" cy="814730"/>
+          </a:xfrm>
+          <a:prstGeom prst="rect">
+            <a:avLst/>
+          </a:prstGeom>
+        </p:spPr>
+      </p:pic>
+      <p:pic>
+        <p:nvPicPr>
+          <p:cNvPr id="3" name="Picture 2" descr="image.png"/>
+          <p:cNvPicPr>
+            <a:picLocks noChangeAspect="1"/>
+          </p:cNvPicPr>
+          <p:nvPr/>
+        </p:nvPicPr>
+        <p:blipFill>
+          <a:blip r:embed="rId3"/>
+          <a:stretch>
+            <a:fillRect/>
+          </a:stretch>
+        </p:blipFill>
+        <p:spPr>
+          <a:xfrm>
+            <a:off x="11055096" y="11887"/>
+            <a:ext cx="1140256" cy="634593"/>
+          </a:xfrm>
+          <a:prstGeom prst="rect">
+            <a:avLst/>
+          </a:prstGeom>
+        </p:spPr>
+      </p:pic>
+      <p:sp>
+        <p:nvSpPr>
+          <p:cNvPr id="4" name="Rounded Rectangle 3"/>
+          <p:cNvSpPr/>
+          <p:nvPr/>
+        </p:nvSpPr>
+        <p:spPr>
+          <a:xfrm>
+            <a:off x="548640" y="594360"/>
+            <a:ext cx="731520" cy="658368"/>
+          </a:xfrm>
+          <a:prstGeom prst="roundRect">
+            <a:avLst/>
+          </a:prstGeom>
+          <a:solidFill>
+            <a:srgbClr val="6A2CC9"/>
+          </a:solidFill>
+          <a:ln>
+            <a:noFill/>
+          </a:ln>
+        </p:spPr>
+        <p:style>
+          <a:lnRef idx="1">
+            <a:schemeClr val="accent1"/>
+          </a:lnRef>
+          <a:fillRef idx="3">
+            <a:schemeClr val="accent1"/>
+          </a:fillRef>
+          <a:effectRef idx="2">
+            <a:schemeClr val="accent1"/>
+          </a:effectRef>
+          <a:fontRef idx="minor">
+            <a:schemeClr val="lt1"/>
+          </a:fontRef>
+        </p:style>
+        <p:txBody>
+          <a:bodyPr rtlCol="0" anchor="ctr" wrap="none" lIns="0" tIns="0" rIns="0" bIns="0"/>
+          <a:lstStyle/>
+          <a:p>
+            <a:pPr algn="ctr"/>
+            <a:r>
+              <a:rPr sz="2000" b="1">
+                <a:solidFill>
+                  <a:srgbClr val="FFFFFF"/>
+                </a:solidFill>
+                <a:latin typeface="Arial"/>
+              </a:rPr>
+              <a:t>03.2</a:t>
+            </a:r>
+          </a:p>
+        </p:txBody>
+      </p:sp>
+      <p:sp>
+        <p:nvSpPr>
+          <p:cNvPr id="5" name="TextBox 4"/>
+          <p:cNvSpPr txBox="1"/>
+          <p:nvPr/>
+        </p:nvSpPr>
+        <p:spPr>
+          <a:xfrm>
+            <a:off x="1417320" y="548640"/>
+            <a:ext cx="9326880" cy="731520"/>
+          </a:xfrm>
+          <a:prstGeom prst="rect">
+            <a:avLst/>
+          </a:prstGeom>
+          <a:noFill/>
+        </p:spPr>
+        <p:txBody>
+          <a:bodyPr wrap="square" lIns="0" tIns="0" rIns="0" bIns="0">
+            <a:spAutoFit/>
+          </a:bodyPr>
+          <a:lstStyle/>
+          <a:p>
+            <a:pPr algn="l"/>
+            <a:r>
+              <a:rPr sz="2400" b="1">
+                <a:solidFill>
+                  <a:srgbClr val="20288F"/>
+                </a:solidFill>
+                <a:latin typeface="Arial"/>
+              </a:rPr>
+              <a:t>Analisis Penyebab: Rantai Kausalitas 5-Why &amp; Akar Masalah</a:t>
+            </a:r>
+          </a:p>
+        </p:txBody>
+      </p:sp>
+      <p:sp>
+        <p:nvSpPr>
+          <p:cNvPr id="6" name="TextBox 5"/>
+          <p:cNvSpPr txBox="1"/>
+          <p:nvPr/>
+        </p:nvSpPr>
+        <p:spPr>
+          <a:xfrm>
+            <a:off x="548640" y="1353312"/>
+            <a:ext cx="10789920" cy="347472"/>
+          </a:xfrm>
+          <a:prstGeom prst="rect">
+            <a:avLst/>
+          </a:prstGeom>
+          <a:noFill/>
+        </p:spPr>
+        <p:txBody>
+          <a:bodyPr wrap="square" lIns="0" tIns="0" rIns="0" bIns="0">
+            <a:spAutoFit/>
+          </a:bodyPr>
+          <a:lstStyle/>
+          <a:p>
+            <a:r>
+              <a:rPr sz="1150" b="1">
+                <a:solidFill>
+                  <a:srgbClr val="6A2CC9"/>
+                </a:solidFill>
+                <a:latin typeface="Arial"/>
+              </a:rPr>
+              <a:t>Tujuan bagian ini:  </a:t>
+            </a:r>
+            <a:r>
+              <a:rPr sz="1150" b="0">
+                <a:solidFill>
+                  <a:srgbClr val="2A2A3D"/>
+                </a:solidFill>
+                <a:latin typeface="Arial"/>
+              </a:rPr>
+              <a:t>Buktikan penelusuran kausalitas berjenjang (5-Why) dan rumuskan akar masalah utama yang akan diserang oleh solusi.</a:t>
+            </a:r>
+          </a:p>
+        </p:txBody>
+      </p:sp>
+      <p:sp>
+        <p:nvSpPr>
+          <p:cNvPr id="7" name="TextBox 6"/>
+          <p:cNvSpPr txBox="1"/>
+          <p:nvPr/>
+        </p:nvSpPr>
+        <p:spPr>
+          <a:xfrm>
+            <a:off x="548640" y="6419088"/>
+            <a:ext cx="11091672" cy="219456"/>
+          </a:xfrm>
+          <a:prstGeom prst="rect">
+            <a:avLst/>
+          </a:prstGeom>
+          <a:noFill/>
+        </p:spPr>
+        <p:txBody>
+          <a:bodyPr wrap="square" lIns="0" tIns="0" rIns="0" bIns="0">
+            <a:spAutoFit/>
+          </a:bodyPr>
+          <a:lstStyle/>
+          <a:p>
+            <a:r>
+              <a:rPr sz="850">
+                <a:solidFill>
+                  <a:srgbClr val="6E6E82"/>
+                </a:solidFill>
+                <a:latin typeface="Arial"/>
+              </a:rPr>
+              <a:t>IAKA 2026 — Kerangka Presentasi Peserta  ·  DSS SIRINE 4.0 Unit Cetak Pita Cukai</a:t>
+            </a:r>
+          </a:p>
+        </p:txBody>
+      </p:sp>
+      <p:sp>
+        <p:nvSpPr>
+          <p:cNvPr id="8" name="Rectangle 7"/>
+          <p:cNvSpPr/>
+          <p:nvPr/>
+        </p:nvSpPr>
+        <p:spPr>
+          <a:xfrm>
+            <a:off x="548640" y="1755648"/>
+            <a:ext cx="5577840" cy="329184"/>
+          </a:xfrm>
+          <a:prstGeom prst="rect">
+            <a:avLst/>
+          </a:prstGeom>
+          <a:solidFill>
+            <a:srgbClr val="20288F"/>
+          </a:solidFill>
+          <a:ln>
+            <a:noFill/>
+          </a:ln>
+        </p:spPr>
+        <p:style>
+          <a:lnRef idx="1">
+            <a:schemeClr val="accent1"/>
+          </a:lnRef>
+          <a:fillRef idx="3">
+            <a:schemeClr val="accent1"/>
+          </a:fillRef>
+          <a:effectRef idx="2">
+            <a:schemeClr val="accent1"/>
+          </a:effectRef>
+          <a:fontRef idx="minor">
+            <a:schemeClr val="lt1"/>
+          </a:fontRef>
+        </p:style>
+        <p:txBody>
+          <a:bodyPr rtlCol="0" anchor="ctr" tIns="36576" bIns="36576"/>
+          <a:lstStyle/>
+          <a:p>
+            <a:pPr algn="ctr"/>
+            <a:r>
+              <a:rPr sz="1050" b="1">
+                <a:solidFill>
+                  <a:srgbClr val="FFFFFF"/>
+                </a:solidFill>
+                <a:latin typeface="Arial"/>
+              </a:rPr>
+              <a:t>1. METODE ANALISIS: PENELUSURAN KAUSALITAS 5-WHY</a:t>
+            </a:r>
+          </a:p>
+        </p:txBody>
+      </p:sp>
+      <p:sp>
+        <p:nvSpPr>
+          <p:cNvPr id="9" name="Rounded Rectangle 8"/>
+          <p:cNvSpPr/>
+          <p:nvPr/>
+        </p:nvSpPr>
+        <p:spPr>
+          <a:xfrm>
+            <a:off x="548640" y="2084831"/>
+            <a:ext cx="5577840" cy="3730752"/>
+          </a:xfrm>
+          <a:prstGeom prst="roundRect">
+            <a:avLst/>
+          </a:prstGeom>
+          <a:solidFill>
+            <a:srgbClr val="F4F7FE"/>
+          </a:solidFill>
+          <a:ln>
+            <a:solidFill>
+              <a:srgbClr val="D2DCF5"/>
+            </a:solidFill>
+          </a:ln>
+        </p:spPr>
+        <p:style>
+          <a:lnRef idx="1">
+            <a:schemeClr val="accent1"/>
+          </a:lnRef>
+          <a:fillRef idx="3">
+            <a:schemeClr val="accent1"/>
+          </a:fillRef>
+          <a:effectRef idx="2">
+            <a:schemeClr val="accent1"/>
+          </a:effectRef>
+          <a:fontRef idx="minor">
+            <a:schemeClr val="lt1"/>
+          </a:fontRef>
+        </p:style>
+        <p:txBody>
+          <a:bodyPr rtlCol="0" anchor="ctr"/>
+          <a:lstStyle/>
+          <a:p>
+            <a:pPr algn="ctr"/>
+          </a:p>
+        </p:txBody>
+      </p:sp>
+      <p:sp>
+        <p:nvSpPr>
+          <p:cNvPr id="10" name="Rounded Rectangle 9"/>
+          <p:cNvSpPr/>
+          <p:nvPr/>
+        </p:nvSpPr>
+        <p:spPr>
+          <a:xfrm>
+            <a:off x="658368" y="2157984"/>
+            <a:ext cx="5358384" cy="658368"/>
+          </a:xfrm>
+          <a:prstGeom prst="roundRect">
+            <a:avLst/>
+          </a:prstGeom>
+          <a:solidFill>
+            <a:srgbClr val="FFFFFF"/>
+          </a:solidFill>
+          <a:ln>
+            <a:solidFill>
+              <a:srgbClr val="D2DCF5"/>
+            </a:solidFill>
+          </a:ln>
+        </p:spPr>
+        <p:style>
+          <a:lnRef idx="1">
+            <a:schemeClr val="accent1"/>
+          </a:lnRef>
+          <a:fillRef idx="3">
+            <a:schemeClr val="accent1"/>
+          </a:fillRef>
+          <a:effectRef idx="2">
+            <a:schemeClr val="accent1"/>
+          </a:effectRef>
+          <a:fontRef idx="minor">
+            <a:schemeClr val="lt1"/>
+          </a:fontRef>
+        </p:style>
+        <p:txBody>
+          <a:bodyPr rtlCol="0" anchor="ctr" wrap="square" lIns="73152" rIns="73152" tIns="27432" bIns="27432"/>
+          <a:lstStyle/>
+          <a:p>
+            <a:pPr algn="ctr">
+              <a:spcAft>
+                <a:spcPts val="150"/>
+              </a:spcAft>
+            </a:pPr>
+            <a:r>
+              <a:rPr sz="780" b="1">
+                <a:solidFill>
+                  <a:srgbClr val="20288F"/>
+                </a:solidFill>
+                <a:latin typeface="Arial"/>
+              </a:rPr>
+              <a:t>[WHY 1] </a:t>
+            </a:r>
+            <a:r>
+              <a:rPr sz="780" b="1">
+                <a:solidFill>
+                  <a:srgbClr val="2A2A3D"/>
+                </a:solidFill>
+                <a:latin typeface="Arial"/>
+              </a:rPr>
+              <a:t>Mengapa inschiet berfluktuasi tinggi pada rata-rata 4,61% (puncak 5,11%)?</a:t>
+            </a:r>
+          </a:p>
+          <a:p>
+            <a:pPr>
+              <a:spcAft>
+                <a:spcPts val="150"/>
+              </a:spcAft>
+            </a:pPr>
+            <a:r>
+              <a:rPr sz="780" b="1">
+                <a:solidFill>
+                  <a:srgbClr val="20288F"/>
+                </a:solidFill>
+                <a:latin typeface="Arial"/>
+              </a:rPr>
+              <a:t>➔ </a:t>
+            </a:r>
+            <a:r>
+              <a:rPr sz="780" b="0">
+                <a:solidFill>
+                  <a:srgbClr val="2A2A3D"/>
+                </a:solidFill>
+                <a:latin typeface="Arial"/>
+              </a:rPr>
+              <a:t>Tindakan servis mesin &amp; coaching operator sering terlambat dan tidak tepat sasaran.</a:t>
+            </a:r>
+          </a:p>
+          <a:p>
+            <a:r>
+              <a:rPr sz="700" i="1">
+                <a:solidFill>
+                  <a:srgbClr val="6E6E82"/>
+                </a:solidFill>
+                <a:latin typeface="Arial"/>
+              </a:rPr>
+              <a:t>   [Bukti: Fluktuasi kuartalan Q1 (4,72%) s.d. Q4 (5,11%) — Sumber: SAP ZPPRSIPPC0012]</a:t>
+            </a:r>
+          </a:p>
+        </p:txBody>
+      </p:sp>
+      <p:sp>
+        <p:nvSpPr>
+          <p:cNvPr id="11" name="Rounded Rectangle 10"/>
+          <p:cNvSpPr/>
+          <p:nvPr/>
+        </p:nvSpPr>
+        <p:spPr>
+          <a:xfrm>
+            <a:off x="658368" y="2843784"/>
+            <a:ext cx="5358384" cy="658368"/>
+          </a:xfrm>
+          <a:prstGeom prst="roundRect">
+            <a:avLst/>
+          </a:prstGeom>
+          <a:solidFill>
+            <a:srgbClr val="FFFFFF"/>
+          </a:solidFill>
+          <a:ln>
+            <a:solidFill>
+              <a:srgbClr val="D2DCF5"/>
+            </a:solidFill>
+          </a:ln>
+        </p:spPr>
+        <p:style>
+          <a:lnRef idx="1">
+            <a:schemeClr val="accent1"/>
+          </a:lnRef>
+          <a:fillRef idx="3">
+            <a:schemeClr val="accent1"/>
+          </a:fillRef>
+          <a:effectRef idx="2">
+            <a:schemeClr val="accent1"/>
+          </a:effectRef>
+          <a:fontRef idx="minor">
+            <a:schemeClr val="lt1"/>
+          </a:fontRef>
+        </p:style>
+        <p:txBody>
+          <a:bodyPr rtlCol="0" anchor="ctr" wrap="square" lIns="73152" rIns="73152" tIns="27432" bIns="27432"/>
+          <a:lstStyle/>
+          <a:p>
+            <a:pPr algn="ctr">
+              <a:spcAft>
+                <a:spcPts val="150"/>
+              </a:spcAft>
+            </a:pPr>
+            <a:r>
+              <a:rPr sz="780" b="1">
+                <a:solidFill>
+                  <a:srgbClr val="20288F"/>
+                </a:solidFill>
+                <a:latin typeface="Arial"/>
+              </a:rPr>
+              <a:t>[WHY 2] </a:t>
+            </a:r>
+            <a:r>
+              <a:rPr sz="780" b="1">
+                <a:solidFill>
+                  <a:srgbClr val="2A2A3D"/>
+                </a:solidFill>
+                <a:latin typeface="Arial"/>
+              </a:rPr>
+              <a:t>Mengapa perbaikan mesin &amp; pembinaan operator tidak tepat sasaran?</a:t>
+            </a:r>
+          </a:p>
+          <a:p>
+            <a:pPr>
+              <a:spcAft>
+                <a:spcPts val="150"/>
+              </a:spcAft>
+            </a:pPr>
+            <a:r>
+              <a:rPr sz="780" b="1">
+                <a:solidFill>
+                  <a:srgbClr val="20288F"/>
+                </a:solidFill>
+                <a:latin typeface="Arial"/>
+              </a:rPr>
+              <a:t>➔ </a:t>
+            </a:r>
+            <a:r>
+              <a:rPr sz="780" b="0">
+                <a:solidFill>
+                  <a:srgbClr val="2A2A3D"/>
+                </a:solidFill>
+                <a:latin typeface="Arial"/>
+              </a:rPr>
+              <a:t>Teknisi &amp; pengawas tidak tahu pasti mesin mana sumber masalah &amp; apakah faktor mesin/shift.</a:t>
+            </a:r>
+          </a:p>
+          <a:p>
+            <a:r>
+              <a:rPr sz="700" i="1">
+                <a:solidFill>
+                  <a:srgbClr val="6E6E82"/>
+                </a:solidFill>
+                <a:latin typeface="Arial"/>
+              </a:rPr>
+              <a:t>   [Bukti: Kasus penelusuran blobor acak ke 6 mesin pada Juni 2025 dengan downtime &gt; 8 jam]</a:t>
+            </a:r>
+          </a:p>
+        </p:txBody>
+      </p:sp>
+      <p:sp>
+        <p:nvSpPr>
+          <p:cNvPr id="12" name="Rounded Rectangle 11"/>
+          <p:cNvSpPr/>
+          <p:nvPr/>
+        </p:nvSpPr>
+        <p:spPr>
+          <a:xfrm>
+            <a:off x="658368" y="3529584"/>
+            <a:ext cx="5358384" cy="658368"/>
+          </a:xfrm>
+          <a:prstGeom prst="roundRect">
+            <a:avLst/>
+          </a:prstGeom>
+          <a:solidFill>
+            <a:srgbClr val="FFFFFF"/>
+          </a:solidFill>
+          <a:ln>
+            <a:solidFill>
+              <a:srgbClr val="D9CEF7"/>
+            </a:solidFill>
+          </a:ln>
+        </p:spPr>
+        <p:style>
+          <a:lnRef idx="1">
+            <a:schemeClr val="accent1"/>
+          </a:lnRef>
+          <a:fillRef idx="3">
+            <a:schemeClr val="accent1"/>
+          </a:fillRef>
+          <a:effectRef idx="2">
+            <a:schemeClr val="accent1"/>
+          </a:effectRef>
+          <a:fontRef idx="minor">
+            <a:schemeClr val="lt1"/>
+          </a:fontRef>
+        </p:style>
+        <p:txBody>
+          <a:bodyPr rtlCol="0" anchor="ctr" wrap="square" lIns="73152" rIns="73152" tIns="27432" bIns="27432"/>
+          <a:lstStyle/>
+          <a:p>
+            <a:pPr algn="ctr">
+              <a:spcAft>
+                <a:spcPts val="150"/>
+              </a:spcAft>
+            </a:pPr>
+            <a:r>
+              <a:rPr sz="780" b="1">
+                <a:solidFill>
+                  <a:srgbClr val="6A2CC9"/>
+                </a:solidFill>
+                <a:latin typeface="Arial"/>
+              </a:rPr>
+              <a:t>[WHY 3] </a:t>
+            </a:r>
+            <a:r>
+              <a:rPr sz="780" b="1">
+                <a:solidFill>
+                  <a:srgbClr val="2A2A3D"/>
+                </a:solidFill>
+                <a:latin typeface="Arial"/>
+              </a:rPr>
+              <a:t>Mengapa tidak diketahui mesin mana dan shift mana yang bermasalah?</a:t>
+            </a:r>
+          </a:p>
+          <a:p>
+            <a:pPr>
+              <a:spcAft>
+                <a:spcPts val="150"/>
+              </a:spcAft>
+            </a:pPr>
+            <a:r>
+              <a:rPr sz="780" b="1">
+                <a:solidFill>
+                  <a:srgbClr val="6A2CC9"/>
+                </a:solidFill>
+                <a:latin typeface="Arial"/>
+              </a:rPr>
+              <a:t>➔ </a:t>
+            </a:r>
+            <a:r>
+              <a:rPr sz="780" b="0">
+                <a:solidFill>
+                  <a:srgbClr val="2A2A3D"/>
+                </a:solidFill>
+                <a:latin typeface="Arial"/>
+              </a:rPr>
+              <a:t>Data jenis kerusakan QC tidak terhubung dengan data penugasan operasional (mesin, shift, PO).</a:t>
+            </a:r>
+          </a:p>
+          <a:p>
+            <a:r>
+              <a:rPr sz="700" i="1">
+                <a:solidFill>
+                  <a:srgbClr val="6E6E82"/>
+                </a:solidFill>
+                <a:latin typeface="Arial"/>
+              </a:rPr>
+              <a:t>   [Bukti: Laporan QC Verifikasi hanya menyajikan total kerusakan general di level unit]</a:t>
+            </a:r>
+          </a:p>
+        </p:txBody>
+      </p:sp>
+      <p:sp>
+        <p:nvSpPr>
+          <p:cNvPr id="13" name="Rounded Rectangle 12"/>
+          <p:cNvSpPr/>
+          <p:nvPr/>
+        </p:nvSpPr>
+        <p:spPr>
+          <a:xfrm>
+            <a:off x="658368" y="4215384"/>
+            <a:ext cx="5358384" cy="658368"/>
+          </a:xfrm>
+          <a:prstGeom prst="roundRect">
+            <a:avLst/>
+          </a:prstGeom>
+          <a:solidFill>
+            <a:srgbClr val="FFFFFF"/>
+          </a:solidFill>
+          <a:ln>
+            <a:solidFill>
+              <a:srgbClr val="D9CEF7"/>
+            </a:solidFill>
+          </a:ln>
+        </p:spPr>
+        <p:style>
+          <a:lnRef idx="1">
+            <a:schemeClr val="accent1"/>
+          </a:lnRef>
+          <a:fillRef idx="3">
+            <a:schemeClr val="accent1"/>
+          </a:fillRef>
+          <a:effectRef idx="2">
+            <a:schemeClr val="accent1"/>
+          </a:effectRef>
+          <a:fontRef idx="minor">
+            <a:schemeClr val="lt1"/>
+          </a:fontRef>
+        </p:style>
+        <p:txBody>
+          <a:bodyPr rtlCol="0" anchor="ctr" wrap="square" lIns="73152" rIns="73152" tIns="27432" bIns="27432"/>
+          <a:lstStyle/>
+          <a:p>
+            <a:pPr algn="ctr">
+              <a:spcAft>
+                <a:spcPts val="150"/>
+              </a:spcAft>
+            </a:pPr>
+            <a:r>
+              <a:rPr sz="780" b="1">
+                <a:solidFill>
+                  <a:srgbClr val="6A2CC9"/>
+                </a:solidFill>
+                <a:latin typeface="Arial"/>
+              </a:rPr>
+              <a:t>[WHY 4] </a:t>
+            </a:r>
+            <a:r>
+              <a:rPr sz="780" b="1">
+                <a:solidFill>
+                  <a:srgbClr val="2A2A3D"/>
+                </a:solidFill>
+                <a:latin typeface="Arial"/>
+              </a:rPr>
+              <a:t>Mengapa data kerusakan dan penugasan operasional tidak terhubung?</a:t>
+            </a:r>
+          </a:p>
+          <a:p>
+            <a:pPr>
+              <a:spcAft>
+                <a:spcPts val="150"/>
+              </a:spcAft>
+            </a:pPr>
+            <a:r>
+              <a:rPr sz="780" b="1">
+                <a:solidFill>
+                  <a:srgbClr val="6A2CC9"/>
+                </a:solidFill>
+                <a:latin typeface="Arial"/>
+              </a:rPr>
+              <a:t>➔ </a:t>
+            </a:r>
+            <a:r>
+              <a:rPr sz="780" b="0">
+                <a:solidFill>
+                  <a:srgbClr val="2A2A3D"/>
+                </a:solidFill>
+                <a:latin typeface="Arial"/>
+              </a:rPr>
+              <a:t>Terjadi Data Silo: data mutu di SAP/QC, penugasan dicatat manual di buku folio meja mesin.</a:t>
+            </a:r>
+          </a:p>
+          <a:p>
+            <a:r>
+              <a:rPr sz="700" i="1">
+                <a:solidFill>
+                  <a:srgbClr val="6E6E82"/>
+                </a:solidFill>
+                <a:latin typeface="Arial"/>
+              </a:rPr>
+              <a:t>   [Bukti: Tabel CSV mentah SAP ZPPRSIPPC0012 vs Buku Folio Fisik Meja Mesin]</a:t>
+            </a:r>
+          </a:p>
+        </p:txBody>
+      </p:sp>
+      <p:sp>
+        <p:nvSpPr>
+          <p:cNvPr id="14" name="Rounded Rectangle 13"/>
+          <p:cNvSpPr/>
+          <p:nvPr/>
+        </p:nvSpPr>
+        <p:spPr>
+          <a:xfrm>
+            <a:off x="658368" y="4901184"/>
+            <a:ext cx="5358384" cy="841248"/>
+          </a:xfrm>
+          <a:prstGeom prst="roundRect">
+            <a:avLst/>
+          </a:prstGeom>
+          <a:solidFill>
+            <a:srgbClr val="FFFFFF"/>
+          </a:solidFill>
+          <a:ln>
+            <a:solidFill>
+              <a:srgbClr val="F5C2C2"/>
+            </a:solidFill>
+          </a:ln>
+        </p:spPr>
+        <p:style>
+          <a:lnRef idx="1">
+            <a:schemeClr val="accent1"/>
+          </a:lnRef>
+          <a:fillRef idx="3">
+            <a:schemeClr val="accent1"/>
+          </a:fillRef>
+          <a:effectRef idx="2">
+            <a:schemeClr val="accent1"/>
+          </a:effectRef>
+          <a:fontRef idx="minor">
+            <a:schemeClr val="lt1"/>
+          </a:fontRef>
+        </p:style>
+        <p:txBody>
+          <a:bodyPr rtlCol="0" anchor="ctr" wrap="square" lIns="73152" rIns="73152" tIns="27432" bIns="27432"/>
+          <a:lstStyle/>
+          <a:p>
+            <a:pPr algn="ctr">
+              <a:spcAft>
+                <a:spcPts val="150"/>
+              </a:spcAft>
+            </a:pPr>
+            <a:r>
+              <a:rPr sz="780" b="1">
+                <a:solidFill>
+                  <a:srgbClr val="C62828"/>
+                </a:solidFill>
+                <a:latin typeface="Arial"/>
+              </a:rPr>
+              <a:t>[WHY 5 (ROOT CAUSE)] </a:t>
+            </a:r>
+            <a:r>
+              <a:rPr sz="780" b="1">
+                <a:solidFill>
+                  <a:srgbClr val="2A2A3D"/>
+                </a:solidFill>
+                <a:latin typeface="Arial"/>
+              </a:rPr>
+              <a:t>Mengapa data terpisah dan dicatat secara manual di buku folio?</a:t>
+            </a:r>
+          </a:p>
+          <a:p>
+            <a:pPr>
+              <a:spcAft>
+                <a:spcPts val="150"/>
+              </a:spcAft>
+            </a:pPr>
+            <a:r>
+              <a:rPr sz="780" b="1">
+                <a:solidFill>
+                  <a:srgbClr val="C62828"/>
+                </a:solidFill>
+                <a:latin typeface="Arial"/>
+              </a:rPr>
+              <a:t>➔ </a:t>
+            </a:r>
+            <a:r>
+              <a:rPr sz="780" b="1">
+                <a:solidFill>
+                  <a:srgbClr val="C62828"/>
+                </a:solidFill>
+                <a:latin typeface="Arial"/>
+              </a:rPr>
+              <a:t>Ketiadaan Decision Support System (DSS) terpadu yang mendigitalisasi input PO di lapangan &amp; menghubungkannya real-time ke data mutu per mesin &amp; shift.</a:t>
+            </a:r>
+          </a:p>
+          <a:p>
+            <a:r>
+              <a:rPr sz="700" i="1">
+                <a:solidFill>
+                  <a:srgbClr val="C62828"/>
+                </a:solidFill>
+                <a:latin typeface="Arial"/>
+              </a:rPr>
+              <a:t>   [Status: Akar Masalah Fundamental yang Belum Pernah Diselesaikan di Unit Cetak]</a:t>
+            </a:r>
+          </a:p>
+        </p:txBody>
+      </p:sp>
+      <p:sp>
+        <p:nvSpPr>
+          <p:cNvPr id="15" name="Rectangle 14"/>
+          <p:cNvSpPr/>
+          <p:nvPr/>
+        </p:nvSpPr>
+        <p:spPr>
+          <a:xfrm>
+            <a:off x="6382512" y="1755648"/>
+            <a:ext cx="5257800" cy="329184"/>
+          </a:xfrm>
+          <a:prstGeom prst="rect">
+            <a:avLst/>
+          </a:prstGeom>
+          <a:solidFill>
+            <a:srgbClr val="6A2CC9"/>
+          </a:solidFill>
+          <a:ln>
+            <a:noFill/>
+          </a:ln>
+        </p:spPr>
+        <p:style>
+          <a:lnRef idx="1">
+            <a:schemeClr val="accent1"/>
+          </a:lnRef>
+          <a:fillRef idx="3">
+            <a:schemeClr val="accent1"/>
+          </a:fillRef>
+          <a:effectRef idx="2">
+            <a:schemeClr val="accent1"/>
+          </a:effectRef>
+          <a:fontRef idx="minor">
+            <a:schemeClr val="lt1"/>
+          </a:fontRef>
+        </p:style>
+        <p:txBody>
+          <a:bodyPr rtlCol="0" anchor="ctr" tIns="36576" bIns="36576"/>
+          <a:lstStyle/>
+          <a:p>
+            <a:pPr algn="ctr"/>
+            <a:r>
+              <a:rPr sz="1050" b="1">
+                <a:solidFill>
+                  <a:srgbClr val="FFFFFF"/>
+                </a:solidFill>
+                <a:latin typeface="Arial"/>
+              </a:rPr>
+              <a:t>2. AKAR MASALAH UTAMA &amp; JEMBATAN MENUJU SOLUSI</a:t>
+            </a:r>
+          </a:p>
+        </p:txBody>
+      </p:sp>
+      <p:sp>
+        <p:nvSpPr>
+          <p:cNvPr id="16" name="Rounded Rectangle 15"/>
+          <p:cNvSpPr/>
+          <p:nvPr/>
+        </p:nvSpPr>
+        <p:spPr>
+          <a:xfrm>
+            <a:off x="6382512" y="2084831"/>
+            <a:ext cx="5257800" cy="3730752"/>
+          </a:xfrm>
+          <a:prstGeom prst="roundRect">
+            <a:avLst/>
+          </a:prstGeom>
+          <a:solidFill>
+            <a:srgbClr val="F8F6FE"/>
+          </a:solidFill>
+          <a:ln>
+            <a:solidFill>
+              <a:srgbClr val="D9CEF7"/>
+            </a:solidFill>
+          </a:ln>
+        </p:spPr>
+        <p:style>
+          <a:lnRef idx="1">
+            <a:schemeClr val="accent1"/>
+          </a:lnRef>
+          <a:fillRef idx="3">
+            <a:schemeClr val="accent1"/>
+          </a:fillRef>
+          <a:effectRef idx="2">
+            <a:schemeClr val="accent1"/>
+          </a:effectRef>
+          <a:fontRef idx="minor">
+            <a:schemeClr val="lt1"/>
+          </a:fontRef>
+        </p:style>
+        <p:txBody>
+          <a:bodyPr rtlCol="0" anchor="ctr"/>
+          <a:lstStyle/>
+          <a:p>
+            <a:pPr algn="ctr"/>
+          </a:p>
+        </p:txBody>
+      </p:sp>
+      <p:sp>
+        <p:nvSpPr>
+          <p:cNvPr id="17" name="Rounded Rectangle 16"/>
+          <p:cNvSpPr/>
+          <p:nvPr/>
+        </p:nvSpPr>
+        <p:spPr>
+          <a:xfrm>
+            <a:off x="6492240" y="2157984"/>
+            <a:ext cx="5038344" cy="1536192"/>
+          </a:xfrm>
+          <a:prstGeom prst="roundRect">
+            <a:avLst/>
+          </a:prstGeom>
+          <a:solidFill>
+            <a:srgbClr val="FFF5F5"/>
+          </a:solidFill>
+          <a:ln>
+            <a:solidFill>
+              <a:srgbClr val="C62828"/>
+            </a:solidFill>
+          </a:ln>
+        </p:spPr>
+        <p:style>
+          <a:lnRef idx="1">
+            <a:schemeClr val="accent1"/>
+          </a:lnRef>
+          <a:fillRef idx="3">
+            <a:schemeClr val="accent1"/>
+          </a:fillRef>
+          <a:effectRef idx="2">
+            <a:schemeClr val="accent1"/>
+          </a:effectRef>
+          <a:fontRef idx="minor">
+            <a:schemeClr val="lt1"/>
+          </a:fontRef>
+        </p:style>
+        <p:txBody>
+          <a:bodyPr rtlCol="0" anchor="ctr" wrap="square" lIns="109728" rIns="109728" tIns="54864" bIns="54864"/>
+          <a:lstStyle/>
+          <a:p>
+            <a:pPr algn="ctr">
+              <a:spcAft>
+                <a:spcPts val="300"/>
+              </a:spcAft>
+            </a:pPr>
+            <a:r>
+              <a:rPr sz="950" b="1">
+                <a:solidFill>
+                  <a:srgbClr val="C62828"/>
+                </a:solidFill>
+                <a:latin typeface="Arial"/>
+              </a:rPr>
+              <a:t>RUMUSAN AKAR MASALAH UTAMA (CORE ROOT CAUSE):</a:t>
+            </a:r>
+          </a:p>
+          <a:p>
+            <a:pPr>
+              <a:spcAft>
+                <a:spcPts val="300"/>
+              </a:spcAft>
+            </a:pPr>
+            <a:r>
+              <a:rPr sz="860" b="1" i="1">
+                <a:solidFill>
+                  <a:srgbClr val="2A2A3D"/>
+                </a:solidFill>
+                <a:latin typeface="Arial"/>
+              </a:rPr>
+              <a:t>“Ketiadaan sistem pendukung keputusan (Decision Support System) yang terintegrasi secara real-time untuk mendigitalisasi rekam jejak produksi per PO di lapangan, serta menghubungkan data kuantitas dan jenis kerusakan secara spesifik ke tingkat mesin dan kondisi operasional (shift/tim kerja).”</a:t>
+            </a:r>
+          </a:p>
+          <a:p>
+            <a:r>
+              <a:rPr sz="780" b="1">
+                <a:solidFill>
+                  <a:srgbClr val="2E7D32"/>
+                </a:solidFill>
+                <a:latin typeface="Arial"/>
+              </a:rPr>
+              <a:t>✓ Status: Tervalidasi 100% via Audit Alur Kerja Unit Cetak 2025</a:t>
+            </a:r>
+          </a:p>
+        </p:txBody>
+      </p:sp>
+      <p:sp>
+        <p:nvSpPr>
+          <p:cNvPr id="18" name="Rounded Rectangle 17"/>
+          <p:cNvSpPr/>
+          <p:nvPr/>
+        </p:nvSpPr>
+        <p:spPr>
+          <a:xfrm>
+            <a:off x="6492240" y="3767328"/>
+            <a:ext cx="5038344" cy="1956816"/>
+          </a:xfrm>
+          <a:prstGeom prst="roundRect">
+            <a:avLst/>
+          </a:prstGeom>
+          <a:solidFill>
+            <a:srgbClr val="FFFFFF"/>
+          </a:solidFill>
+          <a:ln>
+            <a:solidFill>
+              <a:srgbClr val="6A2CC9"/>
+            </a:solidFill>
+          </a:ln>
+        </p:spPr>
+        <p:style>
+          <a:lnRef idx="1">
+            <a:schemeClr val="accent1"/>
+          </a:lnRef>
+          <a:fillRef idx="3">
+            <a:schemeClr val="accent1"/>
+          </a:fillRef>
+          <a:effectRef idx="2">
+            <a:schemeClr val="accent1"/>
+          </a:effectRef>
+          <a:fontRef idx="minor">
+            <a:schemeClr val="lt1"/>
+          </a:fontRef>
+        </p:style>
+        <p:txBody>
+          <a:bodyPr rtlCol="0" anchor="ctr" wrap="square" lIns="109728" rIns="109728" tIns="54864" bIns="54864"/>
+          <a:lstStyle/>
+          <a:p>
+            <a:pPr algn="ctr">
+              <a:spcAft>
+                <a:spcPts val="300"/>
+              </a:spcAft>
+            </a:pPr>
+            <a:r>
+              <a:rPr sz="919" b="1">
+                <a:solidFill>
+                  <a:srgbClr val="6A2CC9"/>
+                </a:solidFill>
+                <a:latin typeface="Arial"/>
+              </a:rPr>
+              <a:t>JEMBATAN LOGIKA SEBAB-AKIBAT MENUJU SOLUSI (POINT 04):</a:t>
+            </a:r>
+          </a:p>
+          <a:p>
+            <a:pPr>
+              <a:spcAft>
+                <a:spcPts val="200"/>
+              </a:spcAft>
+            </a:pPr>
+            <a:r>
+              <a:rPr sz="780" b="1">
+                <a:solidFill>
+                  <a:srgbClr val="6A2CC9"/>
+                </a:solidFill>
+                <a:latin typeface="Arial"/>
+              </a:rPr>
+              <a:t>• 1. Akar Masalah: </a:t>
+            </a:r>
+            <a:r>
+              <a:rPr sz="780" b="0">
+                <a:solidFill>
+                  <a:srgbClr val="2A2A3D"/>
+                </a:solidFill>
+                <a:latin typeface="Arial"/>
+              </a:rPr>
+              <a:t>Ketiadaan DSS terpadu per PO, Mesin, &amp; Shift kerja.</a:t>
+            </a:r>
+          </a:p>
+          <a:p>
+            <a:pPr>
+              <a:spcAft>
+                <a:spcPts val="200"/>
+              </a:spcAft>
+            </a:pPr>
+            <a:r>
+              <a:rPr sz="780" b="1">
+                <a:solidFill>
+                  <a:srgbClr val="20288F"/>
+                </a:solidFill>
+                <a:latin typeface="Arial"/>
+              </a:rPr>
+              <a:t>• 2. Gejala Lapangan: </a:t>
+            </a:r>
+            <a:r>
+              <a:rPr sz="780" b="0">
+                <a:solidFill>
+                  <a:srgbClr val="2A2A3D"/>
+                </a:solidFill>
+                <a:latin typeface="Arial"/>
+              </a:rPr>
+              <a:t>Data Silo -&gt; Maintenance spekulatif (&gt; 8 jam) &amp; evaluasi tertunda.</a:t>
+            </a:r>
+          </a:p>
+          <a:p>
+            <a:pPr>
+              <a:spcAft>
+                <a:spcPts val="200"/>
+              </a:spcAft>
+            </a:pPr>
+            <a:r>
+              <a:rPr sz="780" b="1">
+                <a:solidFill>
+                  <a:srgbClr val="C62828"/>
+                </a:solidFill>
+                <a:latin typeface="Arial"/>
+              </a:rPr>
+              <a:t>• 3. Dampak Terukur: </a:t>
+            </a:r>
+            <a:r>
+              <a:rPr sz="780" b="0">
+                <a:solidFill>
+                  <a:srgbClr val="2A2A3D"/>
+                </a:solidFill>
+                <a:latin typeface="Arial"/>
+              </a:rPr>
+              <a:t>Inschiet 4,61% (Potensi pemborosan biaya Rp 24,56 Miliar/Tahun).</a:t>
+            </a:r>
+          </a:p>
+          <a:p>
+            <a:pPr>
+              <a:spcAft>
+                <a:spcPts val="200"/>
+              </a:spcAft>
+            </a:pPr>
+            <a:r>
+              <a:rPr sz="780" b="1">
+                <a:solidFill>
+                  <a:srgbClr val="2E7D32"/>
+                </a:solidFill>
+                <a:latin typeface="Arial"/>
+              </a:rPr>
+              <a:t>• 4. Sasaran Solusi DSS SIRINE 4.0: </a:t>
+            </a:r>
+            <a:r>
+              <a:rPr sz="780" b="1">
+                <a:solidFill>
+                  <a:srgbClr val="2E7D32"/>
+                </a:solidFill>
+                <a:latin typeface="Arial"/>
+              </a:rPr>
+              <a:t>Menghadirkan Arsitektur Dua Lapisan (Form Input Digital &lt; 30 detik + 6 Modul Preskriptif) untuk menyerang langsung akar masalah Why 5.</a:t>
+            </a:r>
+          </a:p>
+        </p:txBody>
+      </p:sp>
+      <p:sp>
+        <p:nvSpPr>
+          <p:cNvPr id="19" name="Rounded Rectangle 18"/>
+          <p:cNvSpPr/>
+          <p:nvPr/>
+        </p:nvSpPr>
+        <p:spPr>
+          <a:xfrm>
+            <a:off x="548640" y="5888736"/>
+            <a:ext cx="11091672" cy="457200"/>
+          </a:xfrm>
+          <a:prstGeom prst="roundRect">
+            <a:avLst/>
+          </a:prstGeom>
+          <a:solidFill>
+            <a:srgbClr val="F8F6FE"/>
+          </a:solidFill>
+          <a:ln>
+            <a:solidFill>
+              <a:srgbClr val="6A2CC9"/>
+            </a:solidFill>
+          </a:ln>
+        </p:spPr>
+        <p:style>
+          <a:lnRef idx="1">
+            <a:schemeClr val="accent1"/>
+          </a:lnRef>
+          <a:fillRef idx="3">
+            <a:schemeClr val="accent1"/>
+          </a:fillRef>
+          <a:effectRef idx="2">
+            <a:schemeClr val="accent1"/>
+          </a:effectRef>
+          <a:fontRef idx="minor">
+            <a:schemeClr val="lt1"/>
+          </a:fontRef>
+        </p:style>
+        <p:txBody>
+          <a:bodyPr rtlCol="0" anchor="ctr" wrap="square" lIns="109728" rIns="109728" tIns="36576" bIns="36576"/>
+          <a:lstStyle/>
+          <a:p>
+            <a:pPr algn="ctr"/>
+            <a:r>
+              <a:rPr sz="880" b="1">
+                <a:solidFill>
+                  <a:srgbClr val="6A2CC9"/>
+                </a:solidFill>
+                <a:latin typeface="Arial"/>
+              </a:rPr>
+              <a:t>• Keterkaitan dengan Solusi:  </a:t>
+            </a:r>
+            <a:r>
+              <a:rPr sz="880">
+                <a:solidFill>
+                  <a:srgbClr val="2A2A3D"/>
+                </a:solidFill>
+                <a:latin typeface="Arial"/>
+              </a:rPr>
+              <a:t>Inovasi DSS SIRINE 4.0 pada Point 04 secara presisi menyerang akar masalah Why 5: meruntuhkan Data Silo melalui integrasi otomatis Lapisan 1 (Input Digital Lapangan) dan Lapisan 2 (Dasbor Preskriptif Per Mesin &amp; Per Shift) guna mengeliminasi spekulasi teknis.</a:t>
+            </a:r>
+          </a:p>
+        </p:txBody>
+      </p:sp>
+    </p:spTree>
+  </p:cSld>
+  <p:clrMapOvr>
+    <a:masterClrMapping/>
+  </p:clrMapOvr>
+</p:sld>
+</file>
+
+<file path=ppt/slides/slide8.xml><?xml version="1.0" encoding="utf-8"?>
 <p:sld xmlns:a="http://schemas.openxmlformats.org/drawingml/2006/main" xmlns:r="http://schemas.openxmlformats.org/officeDocument/2006/relationships" xmlns:p="http://schemas.openxmlformats.org/presentationml/2006/main">
   <p:cSld name="Slide 6">
     <p:bg>
@@ -8318,7 +10708,7 @@
 </p:sld>
 </file>
 
-<file path=ppt/slides/slide8.xml><?xml version="1.0" encoding="utf-8"?>
+<file path=ppt/slides/slide9.xml><?xml version="1.0" encoding="utf-8"?>
 <p:sld xmlns:a="http://schemas.openxmlformats.org/drawingml/2006/main" xmlns:r="http://schemas.openxmlformats.org/officeDocument/2006/relationships" xmlns:p="http://schemas.openxmlformats.org/presentationml/2006/main">
   <p:cSld name="Slide 7">
     <p:bg>
@@ -8786,484 +11176,6 @@
             <a:extLst>
               <a:ext uri="{FF2B5EF4-FFF2-40B4-BE49-F238E27FC236}">
                 <a16:creationId xmlns:a16="http://schemas.microsoft.com/office/drawing/2014/main" id="{E3189091-A826-254D-C3B7-80DAB4A39AF5}"/>
-              </a:ext>
-            </a:extLst>
-          </p:cNvPr>
-          <p:cNvPicPr>
-            <a:picLocks noChangeAspect="1"/>
-          </p:cNvPicPr>
-          <p:nvPr/>
-        </p:nvPicPr>
-        <p:blipFill>
-          <a:blip r:embed="rId4"/>
-          <a:stretch>
-            <a:fillRect/>
-          </a:stretch>
-        </p:blipFill>
-        <p:spPr>
-          <a:xfrm>
-            <a:off x="-108068" y="-179554"/>
-            <a:ext cx="1448261" cy="814647"/>
-          </a:xfrm>
-          <a:prstGeom prst="rect">
-            <a:avLst/>
-          </a:prstGeom>
-        </p:spPr>
-      </p:pic>
-    </p:spTree>
-  </p:cSld>
-  <p:clrMapOvr>
-    <a:masterClrMapping/>
-  </p:clrMapOvr>
-</p:sld>
-</file>
-
-<file path=ppt/slides/slide9.xml><?xml version="1.0" encoding="utf-8"?>
-<p:sld xmlns:a="http://schemas.openxmlformats.org/drawingml/2006/main" xmlns:r="http://schemas.openxmlformats.org/officeDocument/2006/relationships" xmlns:p="http://schemas.openxmlformats.org/presentationml/2006/main">
-  <p:cSld name="Slide 8">
-    <p:bg>
-      <p:bgPr>
-        <a:solidFill>
-          <a:srgbClr val="FFFFFF"/>
-        </a:solidFill>
-        <a:effectLst/>
-      </p:bgPr>
-    </p:bg>
-    <p:spTree>
-      <p:nvGrpSpPr>
-        <p:cNvPr id="1" name=""/>
-        <p:cNvGrpSpPr/>
-        <p:nvPr/>
-      </p:nvGrpSpPr>
-      <p:grpSpPr>
-        <a:xfrm>
-          <a:off x="0" y="0"/>
-          <a:ext cx="0" cy="0"/>
-          <a:chOff x="0" y="0"/>
-          <a:chExt cx="0" cy="0"/>
-        </a:xfrm>
-      </p:grpSpPr>
-      <p:sp>
-        <p:nvSpPr>
-          <p:cNvPr id="3" name="Shape 1"/>
-          <p:cNvSpPr/>
-          <p:nvPr/>
-        </p:nvSpPr>
-        <p:spPr>
-          <a:xfrm>
-            <a:off x="548640" y="619299"/>
-            <a:ext cx="731520" cy="731520"/>
-          </a:xfrm>
-          <a:prstGeom prst="ellipse">
-            <a:avLst/>
-          </a:prstGeom>
-          <a:solidFill>
-            <a:srgbClr val="6A2CC9"/>
-          </a:solidFill>
-          <a:ln/>
-          <a:effectLst>
-            <a:outerShdw blurRad="101600" dist="25400" dir="5400000" algn="bl" rotWithShape="0">
-              <a:srgbClr val="6A2CC9">
-                <a:alpha val="28000"/>
-              </a:srgbClr>
-            </a:outerShdw>
-          </a:effectLst>
-        </p:spPr>
-      </p:sp>
-      <p:sp>
-        <p:nvSpPr>
-          <p:cNvPr id="4" name="Text 2"/>
-          <p:cNvSpPr/>
-          <p:nvPr/>
-        </p:nvSpPr>
-        <p:spPr>
-          <a:xfrm>
-            <a:off x="548640" y="619299"/>
-            <a:ext cx="731520" cy="731520"/>
-          </a:xfrm>
-          <a:prstGeom prst="rect">
-            <a:avLst/>
-          </a:prstGeom>
-          <a:noFill/>
-          <a:ln/>
-        </p:spPr>
-        <p:txBody>
-          <a:bodyPr wrap="square" lIns="0" tIns="0" rIns="0" bIns="0" rtlCol="0" anchor="ctr"/>
-          <a:lstStyle/>
-          <a:p>
-            <a:pPr marL="0" indent="0" algn="ctr">
-              <a:buNone/>
-            </a:pPr>
-            <a:r>
-              <a:rPr lang="en-US" sz="2200" b="1" dirty="0">
-                <a:solidFill>
-                  <a:srgbClr val="FFFFFF"/>
-                </a:solidFill>
-                <a:latin typeface="Arial" pitchFamily="34" charset="0"/>
-                <a:ea typeface="Arial" pitchFamily="34" charset="-122"/>
-                <a:cs typeface="Arial" pitchFamily="34" charset="-120"/>
-              </a:rPr>
-              <a:t>06</a:t>
-            </a:r>
-            <a:endParaRPr lang="en-US" sz="2200" dirty="0"/>
-          </a:p>
-        </p:txBody>
-      </p:sp>
-      <p:sp>
-        <p:nvSpPr>
-          <p:cNvPr id="5" name="Text 3"/>
-          <p:cNvSpPr/>
-          <p:nvPr/>
-        </p:nvSpPr>
-        <p:spPr>
-          <a:xfrm>
-            <a:off x="1463040" y="606829"/>
-            <a:ext cx="7498080" cy="777240"/>
-          </a:xfrm>
-          <a:prstGeom prst="rect">
-            <a:avLst/>
-          </a:prstGeom>
-          <a:noFill/>
-          <a:ln/>
-        </p:spPr>
-        <p:txBody>
-          <a:bodyPr wrap="square" lIns="0" tIns="0" rIns="0" bIns="0" rtlCol="0" anchor="ctr"/>
-          <a:lstStyle/>
-          <a:p>
-            <a:pPr marL="0" indent="0">
-              <a:buNone/>
-            </a:pPr>
-            <a:r>
-              <a:rPr lang="en-US" sz="3400" b="1" dirty="0">
-                <a:solidFill>
-                  <a:srgbClr val="20288F"/>
-                </a:solidFill>
-                <a:latin typeface="Arial" pitchFamily="34" charset="0"/>
-                <a:ea typeface="Arial" pitchFamily="34" charset="-122"/>
-                <a:cs typeface="Arial" pitchFamily="34" charset="-120"/>
-              </a:rPr>
-              <a:t>Dampak</a:t>
-            </a:r>
-            <a:endParaRPr lang="en-US" sz="3400" dirty="0"/>
-          </a:p>
-        </p:txBody>
-      </p:sp>
-      <p:sp>
-        <p:nvSpPr>
-          <p:cNvPr id="8" name="Text 6"/>
-          <p:cNvSpPr/>
-          <p:nvPr/>
-        </p:nvSpPr>
-        <p:spPr>
-          <a:xfrm>
-            <a:off x="548640" y="1417320"/>
-            <a:ext cx="8229600" cy="548640"/>
-          </a:xfrm>
-          <a:prstGeom prst="rect">
-            <a:avLst/>
-          </a:prstGeom>
-          <a:noFill/>
-          <a:ln/>
-        </p:spPr>
-        <p:txBody>
-          <a:bodyPr wrap="square" lIns="0" tIns="0" rIns="0" bIns="0" rtlCol="0" anchor="ctr"/>
-          <a:lstStyle/>
-          <a:p>
-            <a:pPr marL="0" indent="0">
-              <a:buNone/>
-            </a:pPr>
-            <a:r>
-              <a:rPr lang="en-US" sz="1450" b="1" i="1" dirty="0">
-                <a:solidFill>
-                  <a:srgbClr val="6A2CC9"/>
-                </a:solidFill>
-                <a:latin typeface="Arial" pitchFamily="34" charset="0"/>
-                <a:ea typeface="Arial" pitchFamily="34" charset="-122"/>
-                <a:cs typeface="Arial" pitchFamily="34" charset="-120"/>
-              </a:rPr>
-              <a:t>Tujuan bagian ini:  </a:t>
-            </a:r>
-            <a:r>
-              <a:rPr lang="en-US" sz="1450" i="1" dirty="0">
-                <a:solidFill>
-                  <a:srgbClr val="33334D"/>
-                </a:solidFill>
-                <a:latin typeface="Arial" pitchFamily="34" charset="0"/>
-                <a:ea typeface="Arial" pitchFamily="34" charset="-122"/>
-                <a:cs typeface="Arial" pitchFamily="34" charset="-120"/>
-              </a:rPr>
-              <a:t>Sajikan dampak yang sudah tervalidasi — finansial dan non-finansial.</a:t>
-            </a:r>
-            <a:endParaRPr lang="en-US" sz="1450" dirty="0"/>
-          </a:p>
-        </p:txBody>
-      </p:sp>
-      <p:sp>
-        <p:nvSpPr>
-          <p:cNvPr id="9" name="Shape 7"/>
-          <p:cNvSpPr/>
-          <p:nvPr/>
-        </p:nvSpPr>
-        <p:spPr>
-          <a:xfrm>
-            <a:off x="548640" y="2148840"/>
-            <a:ext cx="7955280" cy="3703320"/>
-          </a:xfrm>
-          <a:prstGeom prst="roundRect">
-            <a:avLst>
-              <a:gd name="adj" fmla="val 2963"/>
-            </a:avLst>
-          </a:prstGeom>
-          <a:solidFill>
-            <a:srgbClr val="F5F1FF"/>
-          </a:solidFill>
-          <a:ln w="12700">
-            <a:solidFill>
-              <a:srgbClr val="EFE7FF"/>
-            </a:solidFill>
-            <a:prstDash val="solid"/>
-          </a:ln>
-          <a:effectLst>
-            <a:outerShdw blurRad="101600" dist="25400" dir="5400000" algn="bl" rotWithShape="0">
-              <a:srgbClr val="C9BEE8">
-                <a:alpha val="30000"/>
-              </a:srgbClr>
-            </a:outerShdw>
-          </a:effectLst>
-        </p:spPr>
-      </p:sp>
-      <p:sp>
-        <p:nvSpPr>
-          <p:cNvPr id="10" name="Text 8"/>
-          <p:cNvSpPr/>
-          <p:nvPr/>
-        </p:nvSpPr>
-        <p:spPr>
-          <a:xfrm>
-            <a:off x="868680" y="2377440"/>
-            <a:ext cx="7315200" cy="365760"/>
-          </a:xfrm>
-          <a:prstGeom prst="rect">
-            <a:avLst/>
-          </a:prstGeom>
-          <a:noFill/>
-          <a:ln/>
-        </p:spPr>
-        <p:txBody>
-          <a:bodyPr wrap="square" lIns="0" tIns="0" rIns="0" bIns="0" rtlCol="0" anchor="ctr"/>
-          <a:lstStyle/>
-          <a:p>
-            <a:pPr marL="0" indent="0">
-              <a:buNone/>
-            </a:pPr>
-            <a:r>
-              <a:rPr lang="en-US" sz="1600" b="1" dirty="0">
-                <a:solidFill>
-                  <a:srgbClr val="6A2CC9"/>
-                </a:solidFill>
-                <a:latin typeface="Arial" pitchFamily="34" charset="0"/>
-                <a:ea typeface="Arial" pitchFamily="34" charset="-122"/>
-                <a:cs typeface="Arial" pitchFamily="34" charset="-120"/>
-              </a:rPr>
-              <a:t>Yang harus disampaikan</a:t>
-            </a:r>
-            <a:endParaRPr lang="en-US" sz="1600" dirty="0"/>
-          </a:p>
-        </p:txBody>
-      </p:sp>
-      <p:sp>
-        <p:nvSpPr>
-          <p:cNvPr id="11" name="Text 9"/>
-          <p:cNvSpPr/>
-          <p:nvPr/>
-        </p:nvSpPr>
-        <p:spPr>
-          <a:xfrm>
-            <a:off x="914400" y="2880360"/>
-            <a:ext cx="7223760" cy="2697480"/>
-          </a:xfrm>
-          <a:prstGeom prst="rect">
-            <a:avLst/>
-          </a:prstGeom>
-          <a:noFill/>
-          <a:ln/>
-        </p:spPr>
-        <p:txBody>
-          <a:bodyPr wrap="square" lIns="0" tIns="0" rIns="0" bIns="0" rtlCol="0" anchor="t"/>
-          <a:lstStyle/>
-          <a:p>
-            <a:pPr marL="203200" indent="-203200">
-              <a:lnSpc>
-                <a:spcPct val="105000"/>
-              </a:lnSpc>
-              <a:spcAft>
-                <a:spcPts val="1200"/>
-              </a:spcAft>
-              <a:buSzPct val="100000"/>
-              <a:buChar char="•"/>
-            </a:pPr>
-            <a:r>
-              <a:rPr lang="en-US" sz="1450" dirty="0">
-                <a:solidFill>
-                  <a:srgbClr val="33334D"/>
-                </a:solidFill>
-                <a:latin typeface="Arial" pitchFamily="34" charset="0"/>
-                <a:ea typeface="Arial" pitchFamily="34" charset="-122"/>
-                <a:cs typeface="Arial" pitchFamily="34" charset="-120"/>
-              </a:rPr>
-              <a:t>Cost saving / cost avoidance / revenue, diukur vs baseline terverifikasi.</a:t>
-            </a:r>
-            <a:endParaRPr lang="en-US" sz="1450" dirty="0"/>
-          </a:p>
-          <a:p>
-            <a:pPr marL="203200" indent="-203200">
-              <a:lnSpc>
-                <a:spcPct val="105000"/>
-              </a:lnSpc>
-              <a:spcAft>
-                <a:spcPts val="1200"/>
-              </a:spcAft>
-              <a:buSzPct val="100000"/>
-              <a:buChar char="•"/>
-            </a:pPr>
-            <a:r>
-              <a:rPr lang="en-US" sz="1450" dirty="0">
-                <a:solidFill>
-                  <a:srgbClr val="33334D"/>
-                </a:solidFill>
-                <a:latin typeface="Arial" pitchFamily="34" charset="0"/>
-                <a:ea typeface="Arial" pitchFamily="34" charset="-122"/>
-                <a:cs typeface="Arial" pitchFamily="34" charset="-120"/>
-              </a:rPr>
-              <a:t>Nilai bersih &amp; payback period .</a:t>
-            </a:r>
-            <a:endParaRPr lang="en-US" sz="1450" dirty="0"/>
-          </a:p>
-          <a:p>
-            <a:pPr marL="203200" indent="-203200">
-              <a:lnSpc>
-                <a:spcPct val="105000"/>
-              </a:lnSpc>
-              <a:spcAft>
-                <a:spcPts val="1200"/>
-              </a:spcAft>
-              <a:buSzPct val="100000"/>
-              <a:buChar char="•"/>
-            </a:pPr>
-            <a:r>
-              <a:rPr lang="en-US" sz="1450" dirty="0">
-                <a:solidFill>
-                  <a:srgbClr val="33334D"/>
-                </a:solidFill>
-                <a:latin typeface="Arial" pitchFamily="34" charset="0"/>
-                <a:ea typeface="Arial" pitchFamily="34" charset="-122"/>
-                <a:cs typeface="Arial" pitchFamily="34" charset="-120"/>
-              </a:rPr>
-              <a:t>Dampak non-finansial: mutu, K3L, kepatuhan, kepuasan pengguna.</a:t>
-            </a:r>
-            <a:endParaRPr lang="en-US" sz="1450" dirty="0"/>
-          </a:p>
-          <a:p>
-            <a:pPr marL="203200" indent="-203200">
-              <a:lnSpc>
-                <a:spcPct val="105000"/>
-              </a:lnSpc>
-              <a:spcAft>
-                <a:spcPts val="1200"/>
-              </a:spcAft>
-              <a:buSzPct val="100000"/>
-              <a:buChar char="•"/>
-            </a:pPr>
-            <a:r>
-              <a:rPr lang="en-US" sz="1450" dirty="0">
-                <a:solidFill>
-                  <a:srgbClr val="33334D"/>
-                </a:solidFill>
-                <a:latin typeface="Arial" pitchFamily="34" charset="0"/>
-                <a:ea typeface="Arial" pitchFamily="34" charset="-122"/>
-                <a:cs typeface="Arial" pitchFamily="34" charset="-120"/>
-              </a:rPr>
-              <a:t>Keterkaitan dengan strategi perusahaan &amp; potensi replikasi.</a:t>
-            </a:r>
-            <a:endParaRPr lang="en-US" sz="1450" dirty="0"/>
-          </a:p>
-        </p:txBody>
-      </p:sp>
-      <p:sp>
-        <p:nvSpPr>
-          <p:cNvPr id="12" name="Text 10"/>
-          <p:cNvSpPr/>
-          <p:nvPr/>
-        </p:nvSpPr>
-        <p:spPr>
-          <a:xfrm>
-            <a:off x="548640" y="6400800"/>
-            <a:ext cx="11094415" cy="274320"/>
-          </a:xfrm>
-          <a:prstGeom prst="rect">
-            <a:avLst/>
-          </a:prstGeom>
-          <a:noFill/>
-          <a:ln/>
-        </p:spPr>
-        <p:txBody>
-          <a:bodyPr wrap="square" lIns="0" tIns="0" rIns="0" bIns="0" rtlCol="0" anchor="ctr"/>
-          <a:lstStyle/>
-          <a:p>
-            <a:pPr marL="0" indent="0" algn="l">
-              <a:buNone/>
-            </a:pPr>
-            <a:r>
-              <a:rPr lang="en-US" sz="950" i="1" dirty="0">
-                <a:solidFill>
-                  <a:srgbClr val="8A8A9A"/>
-                </a:solidFill>
-                <a:latin typeface="Arial" pitchFamily="34" charset="0"/>
-                <a:ea typeface="Arial" pitchFamily="34" charset="-122"/>
-                <a:cs typeface="Arial" pitchFamily="34" charset="-120"/>
-              </a:rPr>
-              <a:t>Ganti poin di atas dengan konten proyek Anda (grafik, tabel, foto, atau diagram).  ·  IAKA 2026 — Kerangka Presentasi Peserta</a:t>
-            </a:r>
-            <a:endParaRPr lang="en-US" sz="950" dirty="0"/>
-          </a:p>
-        </p:txBody>
-      </p:sp>
-      <p:pic>
-        <p:nvPicPr>
-          <p:cNvPr id="14" name="Picture 13">
-            <a:extLst>
-              <a:ext uri="{FF2B5EF4-FFF2-40B4-BE49-F238E27FC236}">
-                <a16:creationId xmlns:a16="http://schemas.microsoft.com/office/drawing/2014/main" id="{113CABC3-586E-7F22-C24E-7E3D7593E669}"/>
-              </a:ext>
-            </a:extLst>
-          </p:cNvPr>
-          <p:cNvPicPr>
-            <a:picLocks noChangeAspect="1"/>
-          </p:cNvPicPr>
-          <p:nvPr/>
-        </p:nvPicPr>
-        <p:blipFill>
-          <a:blip r:embed="rId3"/>
-          <a:stretch>
-            <a:fillRect/>
-          </a:stretch>
-        </p:blipFill>
-        <p:spPr>
-          <a:xfrm>
-            <a:off x="11056239" y="11533"/>
-            <a:ext cx="1140374" cy="634767"/>
-          </a:xfrm>
-          <a:prstGeom prst="rect">
-            <a:avLst/>
-          </a:prstGeom>
-        </p:spPr>
-      </p:pic>
-      <p:pic>
-        <p:nvPicPr>
-          <p:cNvPr id="16" name="Picture 15">
-            <a:extLst>
-              <a:ext uri="{FF2B5EF4-FFF2-40B4-BE49-F238E27FC236}">
-                <a16:creationId xmlns:a16="http://schemas.microsoft.com/office/drawing/2014/main" id="{A9D540F0-33FD-3602-4087-CD7695575FC6}"/>
               </a:ext>
             </a:extLst>
           </p:cNvPr>

</xml_diff>